<commit_message>
Support Google Vertex AI with local ADC and guided desktop setup
</commit_message>
<xml_diff>
--- a/docs/presentation/Jinni_Code_Walkthrough.pptx
+++ b/docs/presentation/Jinni_Code_Walkthrough.pptx
@@ -19,6 +19,7 @@
     <p:sldId id="267" r:id="rId19"/>
     <p:sldId id="268" r:id="rId20"/>
     <p:sldId id="269" r:id="rId21"/>
+    <p:sldId id="270" r:id="rId22"/>
   </p:sldIdLst>
   <p:sldSz cx="12191695" cy="6858000" type="screen4x3"/>
   <p:notesSz cx="6858000" cy="9144000"/>
@@ -515,7 +516,7 @@
           <a:lstStyle/>
           <a:p>
             <a:r>
-              <a:t>Introduce Jinni as a decision-support prototype. It helps people compare supplied options using their budget, time and priorities, then ask an optional AI to explain the evidence. The built-in examples are fictional. Add your name, teammate names and course or event details before presenting. Do not describe the demo as a live travel or investment service.</a:t>
+              <a:t>Introduce Jinni as a decision-support prototype. It helps people compare supplied options using their budget, time and priorities, then ask an optional cloud AI to explain the evidence. The built-in examples are fictional. Add your name, teammate names and course or event details before presenting. Do not describe the demo as a live travel or investment service.</a:t>
             </a:r>
           </a:p>
           <a:p/>
@@ -783,7 +784,7 @@
           <a:lstStyle/>
           <a:p>
             <a:r>
-              <a:t>The renderer has no Node access and uses a narrow preload bridge. The main process attaches a key only to the selected provider's chat request. The backend validates structured output and exact quotation membership. Instructions inside documents are treated as data, but this and quotation checks are safeguards rather than proof of truth. No matching source passages avoids a provider call. Ordinary comparisons remain available without any AI provider. Text/PDF import is bounded, with no OCR, web scraping or automatic provider fallback.</a:t>
+              <a:t>ADC is Application Default Credentials. The Google Cloud CLI creates it locally; the user does not upload a JSON file or paste an API key into Jinni. The Python backend discovers and refreshes short-lived OAuth tokens for the selected Google Cloud project. The renderer sees only project metadata and safe status. A successful sign-in check does not prove project permissions, model availability, billing eligibility or quota. Select a model actually available in Vertex AI Studio. Google decides whether trial credits apply. Never put credential files or tokens into slides, Git or chat.</a:t>
             </a:r>
           </a:p>
           <a:p/>
@@ -794,22 +795,22 @@
           </a:p>
           <a:p>
             <a:r>
-              <a:t>desktop/preload.cjs</a:t>
-            </a:r>
-          </a:p>
-          <a:p>
-            <a:r>
-              <a:t>desktop/validation.cjs</a:t>
-            </a:r>
-          </a:p>
-          <a:p>
-            <a:r>
-              <a:t>app/knowledge/openai_client.py</a:t>
-            </a:r>
-          </a:p>
-          <a:p>
-            <a:r>
-              <a:t>app/knowledge/storage.py</a:t>
+              <a:t>docs/GOOGLE_ADC_SETUP.md</a:t>
+            </a:r>
+          </a:p>
+          <a:p>
+            <a:r>
+              <a:t>app/knowledge/vertex.py</a:t>
+            </a:r>
+          </a:p>
+          <a:p>
+            <a:r>
+              <a:t>web/desktop-ai.mjs</a:t>
+            </a:r>
+          </a:p>
+          <a:p>
+            <a:r>
+              <a:t>scripts/verify_vertex.py</a:t>
             </a:r>
           </a:p>
         </p:txBody>
@@ -879,7 +880,7 @@
           <a:lstStyle/>
           <a:p>
             <a:r>
-              <a:t>Describe which checks used actual calculations and which used injected cloud responses. The new tests inspect the exact data sent to OpenAI, including units, changed priorities, limits and bounded custom context. A conservative live checker also checks that an example answer says £8.00 and 120 minutes and includes a valid citation. No genuine OpenAI key was configured during this work, so live access remains unverified. Update this slide only after recording a real run; do not claim human review or live success just because automated tests pass.</a:t>
+              <a:t>The renderer has no Node access and uses a narrow preload bridge. The main process attaches a key only to the selected provider's chat request. The backend validates structured output and exact quotation membership. Instructions inside documents are treated as data, but this and quotation checks are safeguards rather than proof of truth. No matching source passages avoids a provider call. Ordinary comparisons remain available without any AI provider. Text/PDF import is bounded, with no OCR, web scraping or automatic provider fallback. ADC uses local Google-managed credentials and backend-only access tokens; the app does not store or return them.</a:t>
             </a:r>
           </a:p>
           <a:p/>
@@ -890,22 +891,22 @@
           </a:p>
           <a:p>
             <a:r>
-              <a:t>tests/test_decision_chat.py</a:t>
-            </a:r>
-          </a:p>
-          <a:p>
-            <a:r>
-              <a:t>tests/test_openai_client.py</a:t>
-            </a:r>
-          </a:p>
-          <a:p>
-            <a:r>
-              <a:t>tests/test_verify_openai.py</a:t>
-            </a:r>
-          </a:p>
-          <a:p>
-            <a:r>
-              <a:t>scripts/verify_openai.py</a:t>
+              <a:t>desktop/preload.cjs</a:t>
+            </a:r>
+          </a:p>
+          <a:p>
+            <a:r>
+              <a:t>desktop/validation.cjs</a:t>
+            </a:r>
+          </a:p>
+          <a:p>
+            <a:r>
+              <a:t>app/knowledge/openai_client.py</a:t>
+            </a:r>
+          </a:p>
+          <a:p>
+            <a:r>
+              <a:t>app/knowledge/storage.py</a:t>
             </a:r>
           </a:p>
         </p:txBody>
@@ -975,13 +976,114 @@
           <a:lstStyle/>
           <a:p>
             <a:r>
-              <a:t>The demo should show a changing calculated result, not just a polished screen. Start keyless, then add optional OpenAI explanation with explicit context. If the provider fails, show the real error and continue using the comparison. Do not improvise a fake AI success. End by explaining one important design choice: exact pence protects money boundaries; pure ranking makes results reproducible; citations let users inspect evidence. Future live-data adapters and hosted browser AI are possible extensions, not current completed features.</a:t>
+              <a:t>Describe which checks used actual calculations and which used injected cloud responses. The new tests inspect the exact data sent to OpenAI, including units, changed priorities, limits and bounded custom context. A conservative live checker also checks that an example answer says £8.00 and 120 minutes and includes a valid citation. No genuine OpenAI key was configured during this work, so live access remains unverified. Update this slide only after recording a real run; do not claim human review or live success just because automated tests pass. ADC tests inject Google credential discovery/refresh and HTTP. Separate Chromium checks exercise the actual shared native-tools form with a fake bridge; they are not Electron window or live Google tests. No genuine Google credentials or live model call were used.</a:t>
             </a:r>
           </a:p>
           <a:p/>
           <a:p>
             <a:r>
               <a:t>Code references:</a:t>
+            </a:r>
+          </a:p>
+          <a:p>
+            <a:r>
+              <a:t>tests/test_decision_chat.py</a:t>
+            </a:r>
+          </a:p>
+          <a:p>
+            <a:r>
+              <a:t>tests/test_openai_client.py</a:t>
+            </a:r>
+          </a:p>
+          <a:p>
+            <a:r>
+              <a:t>tests/test_verify_openai.py</a:t>
+            </a:r>
+          </a:p>
+          <a:p>
+            <a:r>
+              <a:t>scripts/verify_openai.py</a:t>
+            </a:r>
+          </a:p>
+        </p:txBody>
+      </p:sp>
+      <p:sp>
+        <p:nvSpPr>
+          <p:cNvPr id="4" name="Slide Number Placeholder 3"/>
+          <p:cNvSpPr>
+            <a:spLocks noGrp="1"/>
+          </p:cNvSpPr>
+          <p:nvPr>
+            <p:ph type="sldNum" idx="5" sz="quarter"/>
+          </p:nvPr>
+        </p:nvSpPr>
+        <p:spPr/>
+      </p:sp>
+    </p:spTree>
+  </p:cSld>
+  <p:clrMapOvr>
+    <a:masterClrMapping/>
+  </p:clrMapOvr>
+</p:notes>
+</file>
+
+<file path=ppt/notesSlides/notesSlide15.xml><?xml version="1.0" encoding="utf-8"?>
+<p:notes xmlns:a="http://schemas.openxmlformats.org/drawingml/2006/main" xmlns:p="http://schemas.openxmlformats.org/presentationml/2006/main" xmlns:r="http://schemas.openxmlformats.org/officeDocument/2006/relationships">
+  <p:cSld>
+    <p:spTree>
+      <p:nvGrpSpPr>
+        <p:cNvPr id="1" name=""/>
+        <p:cNvGrpSpPr/>
+        <p:nvPr/>
+      </p:nvGrpSpPr>
+      <p:grpSpPr>
+        <a:xfrm>
+          <a:off x="0" y="0"/>
+          <a:ext cx="0" cy="0"/>
+          <a:chOff x="0" y="0"/>
+          <a:chExt cx="0" cy="0"/>
+        </a:xfrm>
+      </p:grpSpPr>
+      <p:sp>
+        <p:nvSpPr>
+          <p:cNvPr id="2" name="Slide Image Placeholder 1"/>
+          <p:cNvSpPr>
+            <a:spLocks noGrp="1"/>
+          </p:cNvSpPr>
+          <p:nvPr>
+            <p:ph type="sldImg" idx="2"/>
+          </p:nvPr>
+        </p:nvSpPr>
+        <p:spPr/>
+      </p:sp>
+      <p:sp>
+        <p:nvSpPr>
+          <p:cNvPr id="3" name="Notes Placeholder 2"/>
+          <p:cNvSpPr>
+            <a:spLocks noGrp="1"/>
+          </p:cNvSpPr>
+          <p:nvPr>
+            <p:ph type="body" idx="3" sz="quarter"/>
+          </p:nvPr>
+        </p:nvSpPr>
+        <p:spPr/>
+        <p:txBody>
+          <a:bodyPr/>
+          <a:lstStyle/>
+          <a:p>
+            <a:r>
+              <a:t>The demo should show a changing calculated result, not just a polished screen. Start keyless, then add optional OpenAI explanation with explicit context. If the provider fails, show the real error and continue using the comparison. Do not improvise a fake AI success. End by explaining one important design choice: exact pence protects money boundaries; pure ranking makes results reproducible; citations let users inspect evidence. Future live-data adapters and hosted browser AI are possible extensions, not current completed features. The ADC check obtains a Google token without making a model request. The separate --ask command requires a model and can consume credits.</a:t>
+            </a:r>
+          </a:p>
+          <a:p/>
+          <a:p>
+            <a:r>
+              <a:t>Code references:</a:t>
+            </a:r>
+          </a:p>
+          <a:p>
+            <a:r>
+              <a:t>docs/GOOGLE_ADC_SETUP.md</a:t>
             </a:r>
           </a:p>
           <a:p>
@@ -1703,7 +1805,7 @@
           <a:lstStyle/>
           <a:p>
             <a:r>
-              <a:t>Tick Include my current comparison before asking. The backend calls the same comparison endpoint used by the normal workflow and inserts its result into temporary decision-context evidence. OpenAI receives the question and bounded evidence through the Responses API. The request uses a strict JSON schema, store false and a 30-second deadline. The final response includes the authoritative calculated decision separately from the AI prose. No API key or chat history is written to the source library.</a:t>
+              <a:t>Tick Include my current comparison before asking. The backend calls the same comparison endpoint used by the normal workflow and inserts its result into temporary decision-context evidence. OpenAI receives the question and bounded evidence through the Responses API. The request uses a strict JSON schema, store false and a 30-second deadline. The final response includes the authoritative calculated decision separately from the AI prose. No API key or chat history is written to the source library. Google Vertex AI uses the same evidence and quote checks, with backend-only ADC and native generateContent instead of an API key.</a:t>
             </a:r>
           </a:p>
           <a:p/>
@@ -4944,7 +5046,7 @@
               </a:defRPr>
             </a:pPr>
             <a:r>
-              <a:t>CODE WALKTHROUGH · DESKTOP + OPENAI</a:t>
+              <a:t>CODE WALKTHROUGH · DESKTOP + CLOUD AI</a:t>
             </a:r>
           </a:p>
         </p:txBody>
@@ -5061,7 +5163,7 @@
               </a:defRPr>
             </a:pPr>
             <a:r>
-              <a:t>01 / 14</a:t>
+              <a:t>01 / 15</a:t>
             </a:r>
           </a:p>
         </p:txBody>
@@ -5391,7 +5493,7 @@
               </a:defRPr>
             </a:pPr>
             <a:r>
-              <a:t>Desktop application + optional OpenAI · presentation notes included</a:t>
+              <a:t>Desktop application + optional cloud AI · presentation notes included</a:t>
             </a:r>
           </a:p>
         </p:txBody>
@@ -5667,7 +5769,7 @@
               </a:defRPr>
             </a:pPr>
             <a:r>
-              <a:t>Give the model the meaning of the numbers</a:t>
+              <a:t>Give AI the meaning of the numbers</a:t>
             </a:r>
           </a:p>
         </p:txBody>
@@ -5745,7 +5847,7 @@
               </a:defRPr>
             </a:pPr>
             <a:r>
-              <a:t>10 / 14</a:t>
+              <a:t>10 / 15</a:t>
             </a:r>
           </a:p>
         </p:txBody>
@@ -6618,7 +6720,7 @@
               </a:defRPr>
             </a:pPr>
             <a:r>
-              <a:t>11 / 14</a:t>
+              <a:t>11 / 15</a:t>
             </a:r>
           </a:p>
         </p:txBody>
@@ -7554,7 +7656,7 @@
               </a:defRPr>
             </a:pPr>
             <a:r>
-              <a:t>11 · TRUST BOUNDARIES</a:t>
+              <a:t>11 · GOOGLE VERTEX AI</a:t>
             </a:r>
           </a:p>
         </p:txBody>
@@ -7593,7 +7695,7 @@
               </a:defRPr>
             </a:pPr>
             <a:r>
-              <a:t>Reliability, privacy and honest limits</a:t>
+              <a:t>Google Cloud sign-in: ADC</a:t>
             </a:r>
           </a:p>
         </p:txBody>
@@ -7671,7 +7773,7 @@
               </a:defRPr>
             </a:pPr>
             <a:r>
-              <a:t>12 / 14</a:t>
+              <a:t>12 / 15</a:t>
             </a:r>
           </a:p>
         </p:txBody>
@@ -7684,8 +7786,8 @@
         </p:nvSpPr>
         <p:spPr>
           <a:xfrm>
-            <a:off x="594360" y="2011680"/>
-            <a:ext cx="3532632" cy="2971800"/>
+            <a:off x="594360" y="1828800"/>
+            <a:ext cx="411480" cy="411480"/>
           </a:xfrm>
           <a:prstGeom prst="roundRect">
             <a:avLst>
@@ -7729,25 +7831,25 @@
         </p:nvSpPr>
         <p:spPr>
           <a:xfrm>
-            <a:off x="795528" y="2194560"/>
-            <a:ext cx="3130296" cy="320040"/>
-          </a:xfrm>
-          <a:prstGeom prst="rect">
-            <a:avLst/>
-          </a:prstGeom>
-          <a:noFill/>
-        </p:spPr>
-        <p:txBody>
-          <a:bodyPr wrap="square" lIns="9144" rIns="9144" tIns="0" bIns="0">
-            <a:spAutoFit/>
-          </a:bodyPr>
-          <a:lstStyle/>
-          <a:p>
-            <a:pPr>
-              <a:spcAft>
-                <a:spcPts val="0"/>
-              </a:spcAft>
-              <a:defRPr sz="1400" b="1">
+            <a:off x="694944" y="1883664"/>
+            <a:ext cx="228600" cy="274320"/>
+          </a:xfrm>
+          <a:prstGeom prst="rect">
+            <a:avLst/>
+          </a:prstGeom>
+          <a:noFill/>
+        </p:spPr>
+        <p:txBody>
+          <a:bodyPr wrap="square" lIns="9144" rIns="9144" tIns="0" bIns="0">
+            <a:spAutoFit/>
+          </a:bodyPr>
+          <a:lstStyle/>
+          <a:p>
+            <a:pPr>
+              <a:spcAft>
+                <a:spcPts val="0"/>
+              </a:spcAft>
+              <a:defRPr sz="1600" b="1">
                 <a:solidFill>
                   <a:srgbClr val="BC3045"/>
                 </a:solidFill>
@@ -7755,7 +7857,7 @@
               </a:defRPr>
             </a:pPr>
             <a:r>
-              <a:t>01</a:t>
+              <a:t>1</a:t>
             </a:r>
           </a:p>
         </p:txBody>
@@ -7768,47 +7870,8 @@
         </p:nvSpPr>
         <p:spPr>
           <a:xfrm>
-            <a:off x="795528" y="2743200"/>
-            <a:ext cx="3130296" cy="594360"/>
-          </a:xfrm>
-          <a:prstGeom prst="rect">
-            <a:avLst/>
-          </a:prstGeom>
-          <a:noFill/>
-        </p:spPr>
-        <p:txBody>
-          <a:bodyPr wrap="square" lIns="9144" rIns="9144" tIns="0" bIns="0">
-            <a:spAutoFit/>
-          </a:bodyPr>
-          <a:lstStyle/>
-          <a:p>
-            <a:pPr>
-              <a:spcAft>
-                <a:spcPts val="0"/>
-              </a:spcAft>
-              <a:defRPr sz="2300" b="1">
-                <a:solidFill>
-                  <a:srgbClr val="BC3045"/>
-                </a:solidFill>
-                <a:latin typeface="Aptos"/>
-              </a:defRPr>
-            </a:pPr>
-            <a:r>
-              <a:t>Credentials</a:t>
-            </a:r>
-          </a:p>
-        </p:txBody>
-      </p:sp>
-      <p:sp>
-        <p:nvSpPr>
-          <p:cNvPr id="13" name="TextBox 12"/>
-          <p:cNvSpPr txBox="1"/>
-          <p:nvPr/>
-        </p:nvSpPr>
-        <p:spPr>
-          <a:xfrm>
-            <a:off x="795528" y="3520440"/>
-            <a:ext cx="3130296" cy="1280160"/>
+            <a:off x="1188720" y="1847088"/>
+            <a:ext cx="10149840" cy="548640"/>
           </a:xfrm>
           <a:prstGeom prst="rect">
             <a:avLst/>
@@ -7833,21 +7896,21 @@
               </a:defRPr>
             </a:pPr>
             <a:r>
-              <a:t>Keys stay in main-process session memory. Only the selected provider receives its key.</a:t>
-            </a:r>
-          </a:p>
-        </p:txBody>
-      </p:sp>
-      <p:sp>
-        <p:nvSpPr>
-          <p:cNvPr id="14" name="Rounded Rectangle 13"/>
+              <a:t>ADC means the Google sign-in stored on your computer.</a:t>
+            </a:r>
+          </a:p>
+        </p:txBody>
+      </p:sp>
+      <p:sp>
+        <p:nvSpPr>
+          <p:cNvPr id="13" name="Rounded Rectangle 12"/>
           <p:cNvSpPr/>
           <p:nvPr/>
         </p:nvSpPr>
         <p:spPr>
           <a:xfrm>
-            <a:off x="4328160" y="2011680"/>
-            <a:ext cx="3532632" cy="2971800"/>
+            <a:off x="594360" y="2468880"/>
+            <a:ext cx="411480" cy="411480"/>
           </a:xfrm>
           <a:prstGeom prst="roundRect">
             <a:avLst>
@@ -7885,92 +7948,53 @@
       </p:sp>
       <p:sp>
         <p:nvSpPr>
+          <p:cNvPr id="14" name="TextBox 13"/>
+          <p:cNvSpPr txBox="1"/>
+          <p:nvPr/>
+        </p:nvSpPr>
+        <p:spPr>
+          <a:xfrm>
+            <a:off x="694944" y="2523744"/>
+            <a:ext cx="228600" cy="274320"/>
+          </a:xfrm>
+          <a:prstGeom prst="rect">
+            <a:avLst/>
+          </a:prstGeom>
+          <a:noFill/>
+        </p:spPr>
+        <p:txBody>
+          <a:bodyPr wrap="square" lIns="9144" rIns="9144" tIns="0" bIns="0">
+            <a:spAutoFit/>
+          </a:bodyPr>
+          <a:lstStyle/>
+          <a:p>
+            <a:pPr>
+              <a:spcAft>
+                <a:spcPts val="0"/>
+              </a:spcAft>
+              <a:defRPr sz="1600" b="1">
+                <a:solidFill>
+                  <a:srgbClr val="18704C"/>
+                </a:solidFill>
+                <a:latin typeface="Aptos"/>
+              </a:defRPr>
+            </a:pPr>
+            <a:r>
+              <a:t>2</a:t>
+            </a:r>
+          </a:p>
+        </p:txBody>
+      </p:sp>
+      <p:sp>
+        <p:nvSpPr>
           <p:cNvPr id="15" name="TextBox 14"/>
           <p:cNvSpPr txBox="1"/>
           <p:nvPr/>
         </p:nvSpPr>
         <p:spPr>
           <a:xfrm>
-            <a:off x="4529328" y="2194560"/>
-            <a:ext cx="3130296" cy="320040"/>
-          </a:xfrm>
-          <a:prstGeom prst="rect">
-            <a:avLst/>
-          </a:prstGeom>
-          <a:noFill/>
-        </p:spPr>
-        <p:txBody>
-          <a:bodyPr wrap="square" lIns="9144" rIns="9144" tIns="0" bIns="0">
-            <a:spAutoFit/>
-          </a:bodyPr>
-          <a:lstStyle/>
-          <a:p>
-            <a:pPr>
-              <a:spcAft>
-                <a:spcPts val="0"/>
-              </a:spcAft>
-              <a:defRPr sz="1400" b="1">
-                <a:solidFill>
-                  <a:srgbClr val="18704C"/>
-                </a:solidFill>
-                <a:latin typeface="Aptos"/>
-              </a:defRPr>
-            </a:pPr>
-            <a:r>
-              <a:t>02</a:t>
-            </a:r>
-          </a:p>
-        </p:txBody>
-      </p:sp>
-      <p:sp>
-        <p:nvSpPr>
-          <p:cNvPr id="16" name="TextBox 15"/>
-          <p:cNvSpPr txBox="1"/>
-          <p:nvPr/>
-        </p:nvSpPr>
-        <p:spPr>
-          <a:xfrm>
-            <a:off x="4529328" y="2743200"/>
-            <a:ext cx="3130296" cy="594360"/>
-          </a:xfrm>
-          <a:prstGeom prst="rect">
-            <a:avLst/>
-          </a:prstGeom>
-          <a:noFill/>
-        </p:spPr>
-        <p:txBody>
-          <a:bodyPr wrap="square" lIns="9144" rIns="9144" tIns="0" bIns="0">
-            <a:spAutoFit/>
-          </a:bodyPr>
-          <a:lstStyle/>
-          <a:p>
-            <a:pPr>
-              <a:spcAft>
-                <a:spcPts val="0"/>
-              </a:spcAft>
-              <a:defRPr sz="2300" b="1">
-                <a:solidFill>
-                  <a:srgbClr val="18704C"/>
-                </a:solidFill>
-                <a:latin typeface="Aptos"/>
-              </a:defRPr>
-            </a:pPr>
-            <a:r>
-              <a:t>Evidence</a:t>
-            </a:r>
-          </a:p>
-        </p:txBody>
-      </p:sp>
-      <p:sp>
-        <p:nvSpPr>
-          <p:cNvPr id="17" name="TextBox 16"/>
-          <p:cNvSpPr txBox="1"/>
-          <p:nvPr/>
-        </p:nvSpPr>
-        <p:spPr>
-          <a:xfrm>
-            <a:off x="4529328" y="3520440"/>
-            <a:ext cx="3130296" cy="1280160"/>
+            <a:off x="1188720" y="2487168"/>
+            <a:ext cx="10149840" cy="548640"/>
           </a:xfrm>
           <a:prstGeom prst="rect">
             <a:avLst/>
@@ -7995,21 +8019,21 @@
               </a:defRPr>
             </a:pPr>
             <a:r>
-              <a:t>Every accepted quote must match selected evidence. Quote checks do not prove every claim.</a:t>
-            </a:r>
-          </a:p>
-        </p:txBody>
-      </p:sp>
-      <p:sp>
-        <p:nvSpPr>
-          <p:cNvPr id="18" name="Rounded Rectangle 17"/>
+              <a:t>Sign in using gcloud auth application-default login.</a:t>
+            </a:r>
+          </a:p>
+        </p:txBody>
+      </p:sp>
+      <p:sp>
+        <p:nvSpPr>
+          <p:cNvPr id="16" name="Rounded Rectangle 15"/>
           <p:cNvSpPr/>
           <p:nvPr/>
         </p:nvSpPr>
         <p:spPr>
           <a:xfrm>
-            <a:off x="8061960" y="2011680"/>
-            <a:ext cx="3532632" cy="2971800"/>
+            <a:off x="594360" y="3108960"/>
+            <a:ext cx="411480" cy="411480"/>
           </a:xfrm>
           <a:prstGeom prst="roundRect">
             <a:avLst>
@@ -8047,31 +8071,31 @@
       </p:sp>
       <p:sp>
         <p:nvSpPr>
-          <p:cNvPr id="19" name="TextBox 18"/>
-          <p:cNvSpPr txBox="1"/>
-          <p:nvPr/>
-        </p:nvSpPr>
-        <p:spPr>
-          <a:xfrm>
-            <a:off x="8263128" y="2194560"/>
-            <a:ext cx="3130296" cy="320040"/>
-          </a:xfrm>
-          <a:prstGeom prst="rect">
-            <a:avLst/>
-          </a:prstGeom>
-          <a:noFill/>
-        </p:spPr>
-        <p:txBody>
-          <a:bodyPr wrap="square" lIns="9144" rIns="9144" tIns="0" bIns="0">
-            <a:spAutoFit/>
-          </a:bodyPr>
-          <a:lstStyle/>
-          <a:p>
-            <a:pPr>
-              <a:spcAft>
-                <a:spcPts val="0"/>
-              </a:spcAft>
-              <a:defRPr sz="1400" b="1">
+          <p:cNvPr id="17" name="TextBox 16"/>
+          <p:cNvSpPr txBox="1"/>
+          <p:nvPr/>
+        </p:nvSpPr>
+        <p:spPr>
+          <a:xfrm>
+            <a:off x="694944" y="3163824"/>
+            <a:ext cx="228600" cy="274320"/>
+          </a:xfrm>
+          <a:prstGeom prst="rect">
+            <a:avLst/>
+          </a:prstGeom>
+          <a:noFill/>
+        </p:spPr>
+        <p:txBody>
+          <a:bodyPr wrap="square" lIns="9144" rIns="9144" tIns="0" bIns="0">
+            <a:spAutoFit/>
+          </a:bodyPr>
+          <a:lstStyle/>
+          <a:p>
+            <a:pPr>
+              <a:spcAft>
+                <a:spcPts val="0"/>
+              </a:spcAft>
+              <a:defRPr sz="1600" b="1">
                 <a:solidFill>
                   <a:srgbClr val="255EC9"/>
                 </a:solidFill>
@@ -8079,8 +8103,92 @@
               </a:defRPr>
             </a:pPr>
             <a:r>
-              <a:t>03</a:t>
-            </a:r>
+              <a:t>3</a:t>
+            </a:r>
+          </a:p>
+        </p:txBody>
+      </p:sp>
+      <p:sp>
+        <p:nvSpPr>
+          <p:cNvPr id="18" name="TextBox 17"/>
+          <p:cNvSpPr txBox="1"/>
+          <p:nvPr/>
+        </p:nvSpPr>
+        <p:spPr>
+          <a:xfrm>
+            <a:off x="1188720" y="3127248"/>
+            <a:ext cx="10149840" cy="548640"/>
+          </a:xfrm>
+          <a:prstGeom prst="rect">
+            <a:avLst/>
+          </a:prstGeom>
+          <a:noFill/>
+        </p:spPr>
+        <p:txBody>
+          <a:bodyPr wrap="square" lIns="9144" rIns="9144" tIns="0" bIns="0">
+            <a:spAutoFit/>
+          </a:bodyPr>
+          <a:lstStyle/>
+          <a:p>
+            <a:pPr>
+              <a:spcAft>
+                <a:spcPts val="0"/>
+              </a:spcAft>
+              <a:defRPr sz="2000" b="0">
+                <a:solidFill>
+                  <a:srgbClr val="17243B"/>
+                </a:solidFill>
+                <a:latin typeface="Aptos"/>
+              </a:defRPr>
+            </a:pPr>
+            <a:r>
+              <a:t>Choose Google Vertex AI (ADC) in Ask AI.</a:t>
+            </a:r>
+          </a:p>
+        </p:txBody>
+      </p:sp>
+      <p:sp>
+        <p:nvSpPr>
+          <p:cNvPr id="19" name="Rounded Rectangle 18"/>
+          <p:cNvSpPr/>
+          <p:nvPr/>
+        </p:nvSpPr>
+        <p:spPr>
+          <a:xfrm>
+            <a:off x="594360" y="3749039"/>
+            <a:ext cx="411480" cy="411480"/>
+          </a:xfrm>
+          <a:prstGeom prst="roundRect">
+            <a:avLst>
+              <a:gd name="adj" fmla="val 8000"/>
+            </a:avLst>
+          </a:prstGeom>
+          <a:solidFill>
+            <a:srgbClr val="FFF7DB"/>
+          </a:solidFill>
+          <a:ln>
+            <a:noFill/>
+          </a:ln>
+        </p:spPr>
+        <p:style>
+          <a:lnRef idx="1">
+            <a:schemeClr val="accent1"/>
+          </a:lnRef>
+          <a:fillRef idx="3">
+            <a:schemeClr val="accent1"/>
+          </a:fillRef>
+          <a:effectRef idx="2">
+            <a:schemeClr val="accent1"/>
+          </a:effectRef>
+          <a:fontRef idx="minor">
+            <a:schemeClr val="lt1"/>
+          </a:fontRef>
+        </p:style>
+        <p:txBody>
+          <a:bodyPr rtlCol="0" anchor="ctr"/>
+          <a:lstStyle/>
+          <a:p>
+            <a:pPr algn="ctr"/>
           </a:p>
         </p:txBody>
       </p:sp>
@@ -8092,25 +8200,271 @@
         </p:nvSpPr>
         <p:spPr>
           <a:xfrm>
-            <a:off x="8263128" y="2743200"/>
-            <a:ext cx="3130296" cy="594360"/>
-          </a:xfrm>
-          <a:prstGeom prst="rect">
-            <a:avLst/>
-          </a:prstGeom>
-          <a:noFill/>
-        </p:spPr>
-        <p:txBody>
-          <a:bodyPr wrap="square" lIns="9144" rIns="9144" tIns="0" bIns="0">
-            <a:spAutoFit/>
-          </a:bodyPr>
-          <a:lstStyle/>
-          <a:p>
-            <a:pPr>
-              <a:spcAft>
-                <a:spcPts val="0"/>
-              </a:spcAft>
-              <a:defRPr sz="2300" b="1">
+            <a:off x="694944" y="3803903"/>
+            <a:ext cx="228600" cy="274320"/>
+          </a:xfrm>
+          <a:prstGeom prst="rect">
+            <a:avLst/>
+          </a:prstGeom>
+          <a:noFill/>
+        </p:spPr>
+        <p:txBody>
+          <a:bodyPr wrap="square" lIns="9144" rIns="9144" tIns="0" bIns="0">
+            <a:spAutoFit/>
+          </a:bodyPr>
+          <a:lstStyle/>
+          <a:p>
+            <a:pPr>
+              <a:spcAft>
+                <a:spcPts val="0"/>
+              </a:spcAft>
+              <a:defRPr sz="1600" b="1">
+                <a:solidFill>
+                  <a:srgbClr val="8A630A"/>
+                </a:solidFill>
+                <a:latin typeface="Aptos"/>
+              </a:defRPr>
+            </a:pPr>
+            <a:r>
+              <a:t>4</a:t>
+            </a:r>
+          </a:p>
+        </p:txBody>
+      </p:sp>
+      <p:sp>
+        <p:nvSpPr>
+          <p:cNvPr id="21" name="TextBox 20"/>
+          <p:cNvSpPr txBox="1"/>
+          <p:nvPr/>
+        </p:nvSpPr>
+        <p:spPr>
+          <a:xfrm>
+            <a:off x="1188720" y="3767327"/>
+            <a:ext cx="10149840" cy="548640"/>
+          </a:xfrm>
+          <a:prstGeom prst="rect">
+            <a:avLst/>
+          </a:prstGeom>
+          <a:noFill/>
+        </p:spPr>
+        <p:txBody>
+          <a:bodyPr wrap="square" lIns="9144" rIns="9144" tIns="0" bIns="0">
+            <a:spAutoFit/>
+          </a:bodyPr>
+          <a:lstStyle/>
+          <a:p>
+            <a:pPr>
+              <a:spcAft>
+                <a:spcPts val="0"/>
+              </a:spcAft>
+              <a:defRPr sz="2000" b="0">
+                <a:solidFill>
+                  <a:srgbClr val="17243B"/>
+                </a:solidFill>
+                <a:latin typeface="Aptos"/>
+              </a:defRPr>
+            </a:pPr>
+            <a:r>
+              <a:t>Enter your Project ID, location and an available Gemini model ID.</a:t>
+            </a:r>
+          </a:p>
+        </p:txBody>
+      </p:sp>
+      <p:sp>
+        <p:nvSpPr>
+          <p:cNvPr id="22" name="Rounded Rectangle 21"/>
+          <p:cNvSpPr/>
+          <p:nvPr/>
+        </p:nvSpPr>
+        <p:spPr>
+          <a:xfrm>
+            <a:off x="594360" y="4389120"/>
+            <a:ext cx="411480" cy="411480"/>
+          </a:xfrm>
+          <a:prstGeom prst="roundRect">
+            <a:avLst>
+              <a:gd name="adj" fmla="val 8000"/>
+            </a:avLst>
+          </a:prstGeom>
+          <a:solidFill>
+            <a:srgbClr val="FFF0EE"/>
+          </a:solidFill>
+          <a:ln>
+            <a:noFill/>
+          </a:ln>
+        </p:spPr>
+        <p:style>
+          <a:lnRef idx="1">
+            <a:schemeClr val="accent1"/>
+          </a:lnRef>
+          <a:fillRef idx="3">
+            <a:schemeClr val="accent1"/>
+          </a:fillRef>
+          <a:effectRef idx="2">
+            <a:schemeClr val="accent1"/>
+          </a:effectRef>
+          <a:fontRef idx="minor">
+            <a:schemeClr val="lt1"/>
+          </a:fontRef>
+        </p:style>
+        <p:txBody>
+          <a:bodyPr rtlCol="0" anchor="ctr"/>
+          <a:lstStyle/>
+          <a:p>
+            <a:pPr algn="ctr"/>
+          </a:p>
+        </p:txBody>
+      </p:sp>
+      <p:sp>
+        <p:nvSpPr>
+          <p:cNvPr id="23" name="TextBox 22"/>
+          <p:cNvSpPr txBox="1"/>
+          <p:nvPr/>
+        </p:nvSpPr>
+        <p:spPr>
+          <a:xfrm>
+            <a:off x="694944" y="4443983"/>
+            <a:ext cx="228600" cy="274320"/>
+          </a:xfrm>
+          <a:prstGeom prst="rect">
+            <a:avLst/>
+          </a:prstGeom>
+          <a:noFill/>
+        </p:spPr>
+        <p:txBody>
+          <a:bodyPr wrap="square" lIns="9144" rIns="9144" tIns="0" bIns="0">
+            <a:spAutoFit/>
+          </a:bodyPr>
+          <a:lstStyle/>
+          <a:p>
+            <a:pPr>
+              <a:spcAft>
+                <a:spcPts val="0"/>
+              </a:spcAft>
+              <a:defRPr sz="1600" b="1">
+                <a:solidFill>
+                  <a:srgbClr val="BC3045"/>
+                </a:solidFill>
+                <a:latin typeface="Aptos"/>
+              </a:defRPr>
+            </a:pPr>
+            <a:r>
+              <a:t>5</a:t>
+            </a:r>
+          </a:p>
+        </p:txBody>
+      </p:sp>
+      <p:sp>
+        <p:nvSpPr>
+          <p:cNvPr id="24" name="TextBox 23"/>
+          <p:cNvSpPr txBox="1"/>
+          <p:nvPr/>
+        </p:nvSpPr>
+        <p:spPr>
+          <a:xfrm>
+            <a:off x="1188720" y="4407407"/>
+            <a:ext cx="10149840" cy="548640"/>
+          </a:xfrm>
+          <a:prstGeom prst="rect">
+            <a:avLst/>
+          </a:prstGeom>
+          <a:noFill/>
+        </p:spPr>
+        <p:txBody>
+          <a:bodyPr wrap="square" lIns="9144" rIns="9144" tIns="0" bIns="0">
+            <a:spAutoFit/>
+          </a:bodyPr>
+          <a:lstStyle/>
+          <a:p>
+            <a:pPr>
+              <a:spcAft>
+                <a:spcPts val="0"/>
+              </a:spcAft>
+              <a:defRPr sz="2000" b="0">
+                <a:solidFill>
+                  <a:srgbClr val="17243B"/>
+                </a:solidFill>
+                <a:latin typeface="Aptos"/>
+              </a:defRPr>
+            </a:pPr>
+            <a:r>
+              <a:t>Check Google sign-in, then explicitly ask with your comparison included.</a:t>
+            </a:r>
+          </a:p>
+        </p:txBody>
+      </p:sp>
+      <p:sp>
+        <p:nvSpPr>
+          <p:cNvPr id="25" name="Rounded Rectangle 24"/>
+          <p:cNvSpPr/>
+          <p:nvPr/>
+        </p:nvSpPr>
+        <p:spPr>
+          <a:xfrm>
+            <a:off x="594360" y="5394960"/>
+            <a:ext cx="11000232" cy="749808"/>
+          </a:xfrm>
+          <a:prstGeom prst="roundRect">
+            <a:avLst>
+              <a:gd name="adj" fmla="val 8000"/>
+            </a:avLst>
+          </a:prstGeom>
+          <a:solidFill>
+            <a:srgbClr val="EDF3FF"/>
+          </a:solidFill>
+          <a:ln>
+            <a:noFill/>
+          </a:ln>
+        </p:spPr>
+        <p:style>
+          <a:lnRef idx="1">
+            <a:schemeClr val="accent1"/>
+          </a:lnRef>
+          <a:fillRef idx="3">
+            <a:schemeClr val="accent1"/>
+          </a:fillRef>
+          <a:effectRef idx="2">
+            <a:schemeClr val="accent1"/>
+          </a:effectRef>
+          <a:fontRef idx="minor">
+            <a:schemeClr val="lt1"/>
+          </a:fontRef>
+        </p:style>
+        <p:txBody>
+          <a:bodyPr rtlCol="0" anchor="ctr"/>
+          <a:lstStyle/>
+          <a:p>
+            <a:pPr algn="ctr"/>
+          </a:p>
+        </p:txBody>
+      </p:sp>
+      <p:sp>
+        <p:nvSpPr>
+          <p:cNvPr id="26" name="TextBox 25"/>
+          <p:cNvSpPr txBox="1"/>
+          <p:nvPr/>
+        </p:nvSpPr>
+        <p:spPr>
+          <a:xfrm>
+            <a:off x="822960" y="5559552"/>
+            <a:ext cx="10469880" cy="530352"/>
+          </a:xfrm>
+          <a:prstGeom prst="rect">
+            <a:avLst/>
+          </a:prstGeom>
+          <a:noFill/>
+        </p:spPr>
+        <p:txBody>
+          <a:bodyPr wrap="square" lIns="9144" rIns="9144" tIns="0" bIns="0">
+            <a:spAutoFit/>
+          </a:bodyPr>
+          <a:lstStyle/>
+          <a:p>
+            <a:pPr>
+              <a:spcAft>
+                <a:spcPts val="0"/>
+              </a:spcAft>
+              <a:defRPr sz="1700" b="1">
                 <a:solidFill>
                   <a:srgbClr val="255EC9"/>
                 </a:solidFill>
@@ -8118,85 +8472,7 @@
               </a:defRPr>
             </a:pPr>
             <a:r>
-              <a:t>Failures</a:t>
-            </a:r>
-          </a:p>
-        </p:txBody>
-      </p:sp>
-      <p:sp>
-        <p:nvSpPr>
-          <p:cNvPr id="21" name="TextBox 20"/>
-          <p:cNvSpPr txBox="1"/>
-          <p:nvPr/>
-        </p:nvSpPr>
-        <p:spPr>
-          <a:xfrm>
-            <a:off x="8263128" y="3520440"/>
-            <a:ext cx="3130296" cy="1280160"/>
-          </a:xfrm>
-          <a:prstGeom prst="rect">
-            <a:avLst/>
-          </a:prstGeom>
-          <a:noFill/>
-        </p:spPr>
-        <p:txBody>
-          <a:bodyPr wrap="square" lIns="9144" rIns="9144" tIns="0" bIns="0">
-            <a:spAutoFit/>
-          </a:bodyPr>
-          <a:lstStyle/>
-          <a:p>
-            <a:pPr>
-              <a:spcAft>
-                <a:spcPts val="0"/>
-              </a:spcAft>
-              <a:defRPr sz="2000" b="0">
-                <a:solidFill>
-                  <a:srgbClr val="17243B"/>
-                </a:solidFill>
-                <a:latin typeface="Aptos"/>
-              </a:defRPr>
-            </a:pPr>
-            <a:r>
-              <a:t>Missing evidence, invalid keys, quota limits and timeouts have explicit outcomes.</a:t>
-            </a:r>
-          </a:p>
-        </p:txBody>
-      </p:sp>
-      <p:sp>
-        <p:nvSpPr>
-          <p:cNvPr id="22" name="TextBox 21"/>
-          <p:cNvSpPr txBox="1"/>
-          <p:nvPr/>
-        </p:nvSpPr>
-        <p:spPr>
-          <a:xfrm>
-            <a:off x="640080" y="5833872"/>
-            <a:ext cx="10927080" cy="411480"/>
-          </a:xfrm>
-          <a:prstGeom prst="rect">
-            <a:avLst/>
-          </a:prstGeom>
-          <a:noFill/>
-        </p:spPr>
-        <p:txBody>
-          <a:bodyPr wrap="square" lIns="9144" rIns="9144" tIns="0" bIns="0">
-            <a:spAutoFit/>
-          </a:bodyPr>
-          <a:lstStyle/>
-          <a:p>
-            <a:pPr>
-              <a:spcAft>
-                <a:spcPts val="0"/>
-              </a:spcAft>
-              <a:defRPr sz="1600" b="0">
-                <a:solidFill>
-                  <a:srgbClr val="526078"/>
-                </a:solidFill>
-                <a:latin typeface="Aptos"/>
-              </a:defRPr>
-            </a:pPr>
-            <a:r>
-              <a:t>Source documents are untrusted data. The AI has no tools or authority to change the ranking.</a:t>
+              <a:t>Sign-in checking makes no model request. Asking can consume credits or incur charges.</a:t>
             </a:r>
           </a:p>
         </p:txBody>
@@ -8433,7 +8709,7 @@
               </a:defRPr>
             </a:pPr>
             <a:r>
-              <a:t>12 · VERIFICATION</a:t>
+              <a:t>11 · TRUST BOUNDARIES</a:t>
             </a:r>
           </a:p>
         </p:txBody>
@@ -8472,7 +8748,7 @@
               </a:defRPr>
             </a:pPr>
             <a:r>
-              <a:t>What the checks establish</a:t>
+              <a:t>Reliability, privacy and honest limits</a:t>
             </a:r>
           </a:p>
         </p:txBody>
@@ -8550,7 +8826,7 @@
               </a:defRPr>
             </a:pPr>
             <a:r>
-              <a:t>13 / 14</a:t>
+              <a:t>13 / 15</a:t>
             </a:r>
           </a:p>
         </p:txBody>
@@ -8563,8 +8839,170 @@
         </p:nvSpPr>
         <p:spPr>
           <a:xfrm>
-            <a:off x="594360" y="1810512"/>
-            <a:ext cx="5394960" cy="3858768"/>
+            <a:off x="594360" y="2011680"/>
+            <a:ext cx="3532632" cy="2971800"/>
+          </a:xfrm>
+          <a:prstGeom prst="roundRect">
+            <a:avLst>
+              <a:gd name="adj" fmla="val 8000"/>
+            </a:avLst>
+          </a:prstGeom>
+          <a:solidFill>
+            <a:srgbClr val="FFF0EE"/>
+          </a:solidFill>
+          <a:ln>
+            <a:noFill/>
+          </a:ln>
+        </p:spPr>
+        <p:style>
+          <a:lnRef idx="1">
+            <a:schemeClr val="accent1"/>
+          </a:lnRef>
+          <a:fillRef idx="3">
+            <a:schemeClr val="accent1"/>
+          </a:fillRef>
+          <a:effectRef idx="2">
+            <a:schemeClr val="accent1"/>
+          </a:effectRef>
+          <a:fontRef idx="minor">
+            <a:schemeClr val="lt1"/>
+          </a:fontRef>
+        </p:style>
+        <p:txBody>
+          <a:bodyPr rtlCol="0" anchor="ctr"/>
+          <a:lstStyle/>
+          <a:p>
+            <a:pPr algn="ctr"/>
+          </a:p>
+        </p:txBody>
+      </p:sp>
+      <p:sp>
+        <p:nvSpPr>
+          <p:cNvPr id="11" name="TextBox 10"/>
+          <p:cNvSpPr txBox="1"/>
+          <p:nvPr/>
+        </p:nvSpPr>
+        <p:spPr>
+          <a:xfrm>
+            <a:off x="795528" y="2194560"/>
+            <a:ext cx="3130296" cy="320040"/>
+          </a:xfrm>
+          <a:prstGeom prst="rect">
+            <a:avLst/>
+          </a:prstGeom>
+          <a:noFill/>
+        </p:spPr>
+        <p:txBody>
+          <a:bodyPr wrap="square" lIns="9144" rIns="9144" tIns="0" bIns="0">
+            <a:spAutoFit/>
+          </a:bodyPr>
+          <a:lstStyle/>
+          <a:p>
+            <a:pPr>
+              <a:spcAft>
+                <a:spcPts val="0"/>
+              </a:spcAft>
+              <a:defRPr sz="1400" b="1">
+                <a:solidFill>
+                  <a:srgbClr val="BC3045"/>
+                </a:solidFill>
+                <a:latin typeface="Aptos"/>
+              </a:defRPr>
+            </a:pPr>
+            <a:r>
+              <a:t>01</a:t>
+            </a:r>
+          </a:p>
+        </p:txBody>
+      </p:sp>
+      <p:sp>
+        <p:nvSpPr>
+          <p:cNvPr id="12" name="TextBox 11"/>
+          <p:cNvSpPr txBox="1"/>
+          <p:nvPr/>
+        </p:nvSpPr>
+        <p:spPr>
+          <a:xfrm>
+            <a:off x="795528" y="2743200"/>
+            <a:ext cx="3130296" cy="594360"/>
+          </a:xfrm>
+          <a:prstGeom prst="rect">
+            <a:avLst/>
+          </a:prstGeom>
+          <a:noFill/>
+        </p:spPr>
+        <p:txBody>
+          <a:bodyPr wrap="square" lIns="9144" rIns="9144" tIns="0" bIns="0">
+            <a:spAutoFit/>
+          </a:bodyPr>
+          <a:lstStyle/>
+          <a:p>
+            <a:pPr>
+              <a:spcAft>
+                <a:spcPts val="0"/>
+              </a:spcAft>
+              <a:defRPr sz="2300" b="1">
+                <a:solidFill>
+                  <a:srgbClr val="BC3045"/>
+                </a:solidFill>
+                <a:latin typeface="Aptos"/>
+              </a:defRPr>
+            </a:pPr>
+            <a:r>
+              <a:t>Credentials</a:t>
+            </a:r>
+          </a:p>
+        </p:txBody>
+      </p:sp>
+      <p:sp>
+        <p:nvSpPr>
+          <p:cNvPr id="13" name="TextBox 12"/>
+          <p:cNvSpPr txBox="1"/>
+          <p:nvPr/>
+        </p:nvSpPr>
+        <p:spPr>
+          <a:xfrm>
+            <a:off x="795528" y="3520440"/>
+            <a:ext cx="3130296" cy="1280160"/>
+          </a:xfrm>
+          <a:prstGeom prst="rect">
+            <a:avLst/>
+          </a:prstGeom>
+          <a:noFill/>
+        </p:spPr>
+        <p:txBody>
+          <a:bodyPr wrap="square" lIns="9144" rIns="9144" tIns="0" bIns="0">
+            <a:spAutoFit/>
+          </a:bodyPr>
+          <a:lstStyle/>
+          <a:p>
+            <a:pPr>
+              <a:spcAft>
+                <a:spcPts val="0"/>
+              </a:spcAft>
+              <a:defRPr sz="2000" b="0">
+                <a:solidFill>
+                  <a:srgbClr val="17243B"/>
+                </a:solidFill>
+                <a:latin typeface="Aptos"/>
+              </a:defRPr>
+            </a:pPr>
+            <a:r>
+              <a:t>API keys stay in session memory. Google ADC stays with the local Cloud sign-in.</a:t>
+            </a:r>
+          </a:p>
+        </p:txBody>
+      </p:sp>
+      <p:sp>
+        <p:nvSpPr>
+          <p:cNvPr id="14" name="Rounded Rectangle 13"/>
+          <p:cNvSpPr/>
+          <p:nvPr/>
+        </p:nvSpPr>
+        <p:spPr>
+          <a:xfrm>
+            <a:off x="4328160" y="2011680"/>
+            <a:ext cx="3532632" cy="2971800"/>
           </a:xfrm>
           <a:prstGeom prst="roundRect">
             <a:avLst>
@@ -8602,14 +9040,53 @@
       </p:sp>
       <p:sp>
         <p:nvSpPr>
-          <p:cNvPr id="11" name="TextBox 10"/>
-          <p:cNvSpPr txBox="1"/>
-          <p:nvPr/>
-        </p:nvSpPr>
-        <p:spPr>
-          <a:xfrm>
-            <a:off x="822960" y="2011680"/>
-            <a:ext cx="4919472" cy="411480"/>
+          <p:cNvPr id="15" name="TextBox 14"/>
+          <p:cNvSpPr txBox="1"/>
+          <p:nvPr/>
+        </p:nvSpPr>
+        <p:spPr>
+          <a:xfrm>
+            <a:off x="4529328" y="2194560"/>
+            <a:ext cx="3130296" cy="320040"/>
+          </a:xfrm>
+          <a:prstGeom prst="rect">
+            <a:avLst/>
+          </a:prstGeom>
+          <a:noFill/>
+        </p:spPr>
+        <p:txBody>
+          <a:bodyPr wrap="square" lIns="9144" rIns="9144" tIns="0" bIns="0">
+            <a:spAutoFit/>
+          </a:bodyPr>
+          <a:lstStyle/>
+          <a:p>
+            <a:pPr>
+              <a:spcAft>
+                <a:spcPts val="0"/>
+              </a:spcAft>
+              <a:defRPr sz="1400" b="1">
+                <a:solidFill>
+                  <a:srgbClr val="18704C"/>
+                </a:solidFill>
+                <a:latin typeface="Aptos"/>
+              </a:defRPr>
+            </a:pPr>
+            <a:r>
+              <a:t>02</a:t>
+            </a:r>
+          </a:p>
+        </p:txBody>
+      </p:sp>
+      <p:sp>
+        <p:nvSpPr>
+          <p:cNvPr id="16" name="TextBox 15"/>
+          <p:cNvSpPr txBox="1"/>
+          <p:nvPr/>
+        </p:nvSpPr>
+        <p:spPr>
+          <a:xfrm>
+            <a:off x="4529328" y="2743200"/>
+            <a:ext cx="3130296" cy="594360"/>
           </a:xfrm>
           <a:prstGeom prst="rect">
             <a:avLst/>
@@ -8634,38 +9111,38 @@
               </a:defRPr>
             </a:pPr>
             <a:r>
-              <a:t>Automated verification</a:t>
-            </a:r>
-          </a:p>
-        </p:txBody>
-      </p:sp>
-      <p:sp>
-        <p:nvSpPr>
-          <p:cNvPr id="12" name="TextBox 11"/>
-          <p:cNvSpPr txBox="1"/>
-          <p:nvPr/>
-        </p:nvSpPr>
-        <p:spPr>
-          <a:xfrm>
-            <a:off x="822960" y="2697480"/>
-            <a:ext cx="4892040" cy="658368"/>
-          </a:xfrm>
-          <a:prstGeom prst="rect">
-            <a:avLst/>
-          </a:prstGeom>
-          <a:noFill/>
-        </p:spPr>
-        <p:txBody>
-          <a:bodyPr wrap="square" lIns="9144" rIns="9144" tIns="0" bIns="0">
-            <a:spAutoFit/>
-          </a:bodyPr>
-          <a:lstStyle/>
-          <a:p>
-            <a:pPr>
-              <a:spcAft>
-                <a:spcPts val="0"/>
-              </a:spcAft>
-              <a:defRPr sz="1800" b="0">
+              <a:t>Evidence</a:t>
+            </a:r>
+          </a:p>
+        </p:txBody>
+      </p:sp>
+      <p:sp>
+        <p:nvSpPr>
+          <p:cNvPr id="17" name="TextBox 16"/>
+          <p:cNvSpPr txBox="1"/>
+          <p:nvPr/>
+        </p:nvSpPr>
+        <p:spPr>
+          <a:xfrm>
+            <a:off x="4529328" y="3520440"/>
+            <a:ext cx="3130296" cy="1280160"/>
+          </a:xfrm>
+          <a:prstGeom prst="rect">
+            <a:avLst/>
+          </a:prstGeom>
+          <a:noFill/>
+        </p:spPr>
+        <p:txBody>
+          <a:bodyPr wrap="square" lIns="9144" rIns="9144" tIns="0" bIns="0">
+            <a:spAutoFit/>
+          </a:bodyPr>
+          <a:lstStyle/>
+          <a:p>
+            <a:pPr>
+              <a:spcAft>
+                <a:spcPts val="0"/>
+              </a:spcAft>
+              <a:defRPr sz="2000" b="0">
                 <a:solidFill>
                   <a:srgbClr val="17243B"/>
                 </a:solidFill>
@@ -8673,138 +9150,21 @@
               </a:defRPr>
             </a:pPr>
             <a:r>
-              <a:t>• Budget and time boundaries; missing-data handling</a:t>
-            </a:r>
-          </a:p>
-        </p:txBody>
-      </p:sp>
-      <p:sp>
-        <p:nvSpPr>
-          <p:cNvPr id="13" name="TextBox 12"/>
-          <p:cNvSpPr txBox="1"/>
-          <p:nvPr/>
-        </p:nvSpPr>
-        <p:spPr>
-          <a:xfrm>
-            <a:off x="822960" y="3364992"/>
-            <a:ext cx="4892040" cy="658368"/>
-          </a:xfrm>
-          <a:prstGeom prst="rect">
-            <a:avLst/>
-          </a:prstGeom>
-          <a:noFill/>
-        </p:spPr>
-        <p:txBody>
-          <a:bodyPr wrap="square" lIns="9144" rIns="9144" tIns="0" bIns="0">
-            <a:spAutoFit/>
-          </a:bodyPr>
-          <a:lstStyle/>
-          <a:p>
-            <a:pPr>
-              <a:spcAft>
-                <a:spcPts val="0"/>
-              </a:spcAft>
-              <a:defRPr sz="1800" b="0">
-                <a:solidFill>
-                  <a:srgbClr val="17243B"/>
-                </a:solidFill>
-                <a:latin typeface="Aptos"/>
-              </a:defRPr>
-            </a:pPr>
-            <a:r>
-              <a:t>• All five topics and custom criteria</a:t>
-            </a:r>
-          </a:p>
-        </p:txBody>
-      </p:sp>
-      <p:sp>
-        <p:nvSpPr>
-          <p:cNvPr id="14" name="TextBox 13"/>
-          <p:cNvSpPr txBox="1"/>
-          <p:nvPr/>
-        </p:nvSpPr>
-        <p:spPr>
-          <a:xfrm>
-            <a:off x="822960" y="4032504"/>
-            <a:ext cx="4892040" cy="658368"/>
-          </a:xfrm>
-          <a:prstGeom prst="rect">
-            <a:avLst/>
-          </a:prstGeom>
-          <a:noFill/>
-        </p:spPr>
-        <p:txBody>
-          <a:bodyPr wrap="square" lIns="9144" rIns="9144" tIns="0" bIns="0">
-            <a:spAutoFit/>
-          </a:bodyPr>
-          <a:lstStyle/>
-          <a:p>
-            <a:pPr>
-              <a:spcAft>
-                <a:spcPts val="0"/>
-              </a:spcAft>
-              <a:defRPr sz="1800" b="0">
-                <a:solidFill>
-                  <a:srgbClr val="17243B"/>
-                </a:solidFill>
-                <a:latin typeface="Aptos"/>
-              </a:defRPr>
-            </a:pPr>
-            <a:r>
-              <a:t>• Python/JavaScript response parity</a:t>
-            </a:r>
-          </a:p>
-        </p:txBody>
-      </p:sp>
-      <p:sp>
-        <p:nvSpPr>
-          <p:cNvPr id="15" name="TextBox 14"/>
-          <p:cNvSpPr txBox="1"/>
-          <p:nvPr/>
-        </p:nvSpPr>
-        <p:spPr>
-          <a:xfrm>
-            <a:off x="822960" y="4700016"/>
-            <a:ext cx="4892040" cy="658368"/>
-          </a:xfrm>
-          <a:prstGeom prst="rect">
-            <a:avLst/>
-          </a:prstGeom>
-          <a:noFill/>
-        </p:spPr>
-        <p:txBody>
-          <a:bodyPr wrap="square" lIns="9144" rIns="9144" tIns="0" bIns="0">
-            <a:spAutoFit/>
-          </a:bodyPr>
-          <a:lstStyle/>
-          <a:p>
-            <a:pPr>
-              <a:spcAft>
-                <a:spcPts val="0"/>
-              </a:spcAft>
-              <a:defRPr sz="1800" b="0">
-                <a:solidFill>
-                  <a:srgbClr val="17243B"/>
-                </a:solidFill>
-                <a:latin typeface="Aptos"/>
-              </a:defRPr>
-            </a:pPr>
-            <a:r>
-              <a:t>• Mocked provider requests, citations and safe errors</a:t>
-            </a:r>
-          </a:p>
-        </p:txBody>
-      </p:sp>
-      <p:sp>
-        <p:nvSpPr>
-          <p:cNvPr id="16" name="Rounded Rectangle 15"/>
+              <a:t>Every accepted quote must match selected evidence. Quote checks do not prove every claim.</a:t>
+            </a:r>
+          </a:p>
+        </p:txBody>
+      </p:sp>
+      <p:sp>
+        <p:nvSpPr>
+          <p:cNvPr id="18" name="Rounded Rectangle 17"/>
           <p:cNvSpPr/>
           <p:nvPr/>
         </p:nvSpPr>
         <p:spPr>
           <a:xfrm>
-            <a:off x="6190488" y="1810512"/>
-            <a:ext cx="5394960" cy="3858768"/>
+            <a:off x="8061960" y="2011680"/>
+            <a:ext cx="3532632" cy="2971800"/>
           </a:xfrm>
           <a:prstGeom prst="roundRect">
             <a:avLst>
@@ -8842,14 +9202,53 @@
       </p:sp>
       <p:sp>
         <p:nvSpPr>
-          <p:cNvPr id="17" name="TextBox 16"/>
-          <p:cNvSpPr txBox="1"/>
-          <p:nvPr/>
-        </p:nvSpPr>
-        <p:spPr>
-          <a:xfrm>
-            <a:off x="6419088" y="2011680"/>
-            <a:ext cx="4919472" cy="411480"/>
+          <p:cNvPr id="19" name="TextBox 18"/>
+          <p:cNvSpPr txBox="1"/>
+          <p:nvPr/>
+        </p:nvSpPr>
+        <p:spPr>
+          <a:xfrm>
+            <a:off x="8263128" y="2194560"/>
+            <a:ext cx="3130296" cy="320040"/>
+          </a:xfrm>
+          <a:prstGeom prst="rect">
+            <a:avLst/>
+          </a:prstGeom>
+          <a:noFill/>
+        </p:spPr>
+        <p:txBody>
+          <a:bodyPr wrap="square" lIns="9144" rIns="9144" tIns="0" bIns="0">
+            <a:spAutoFit/>
+          </a:bodyPr>
+          <a:lstStyle/>
+          <a:p>
+            <a:pPr>
+              <a:spcAft>
+                <a:spcPts val="0"/>
+              </a:spcAft>
+              <a:defRPr sz="1400" b="1">
+                <a:solidFill>
+                  <a:srgbClr val="255EC9"/>
+                </a:solidFill>
+                <a:latin typeface="Aptos"/>
+              </a:defRPr>
+            </a:pPr>
+            <a:r>
+              <a:t>03</a:t>
+            </a:r>
+          </a:p>
+        </p:txBody>
+      </p:sp>
+      <p:sp>
+        <p:nvSpPr>
+          <p:cNvPr id="20" name="TextBox 19"/>
+          <p:cNvSpPr txBox="1"/>
+          <p:nvPr/>
+        </p:nvSpPr>
+        <p:spPr>
+          <a:xfrm>
+            <a:off x="8263128" y="2743200"/>
+            <a:ext cx="3130296" cy="594360"/>
           </a:xfrm>
           <a:prstGeom prst="rect">
             <a:avLst/>
@@ -8874,38 +9273,38 @@
               </a:defRPr>
             </a:pPr>
             <a:r>
-              <a:t>Separate live acceptance</a:t>
-            </a:r>
-          </a:p>
-        </p:txBody>
-      </p:sp>
-      <p:sp>
-        <p:nvSpPr>
-          <p:cNvPr id="18" name="TextBox 17"/>
-          <p:cNvSpPr txBox="1"/>
-          <p:nvPr/>
-        </p:nvSpPr>
-        <p:spPr>
-          <a:xfrm>
-            <a:off x="6419088" y="2697480"/>
-            <a:ext cx="4892040" cy="658368"/>
-          </a:xfrm>
-          <a:prstGeom prst="rect">
-            <a:avLst/>
-          </a:prstGeom>
-          <a:noFill/>
-        </p:spPr>
-        <p:txBody>
-          <a:bodyPr wrap="square" lIns="9144" rIns="9144" tIns="0" bIns="0">
-            <a:spAutoFit/>
-          </a:bodyPr>
-          <a:lstStyle/>
-          <a:p>
-            <a:pPr>
-              <a:spcAft>
-                <a:spcPts val="0"/>
-              </a:spcAft>
-              <a:defRPr sz="1800" b="0">
+              <a:t>Failures</a:t>
+            </a:r>
+          </a:p>
+        </p:txBody>
+      </p:sp>
+      <p:sp>
+        <p:nvSpPr>
+          <p:cNvPr id="21" name="TextBox 20"/>
+          <p:cNvSpPr txBox="1"/>
+          <p:nvPr/>
+        </p:nvSpPr>
+        <p:spPr>
+          <a:xfrm>
+            <a:off x="8263128" y="3520440"/>
+            <a:ext cx="3130296" cy="1280160"/>
+          </a:xfrm>
+          <a:prstGeom prst="rect">
+            <a:avLst/>
+          </a:prstGeom>
+          <a:noFill/>
+        </p:spPr>
+        <p:txBody>
+          <a:bodyPr wrap="square" lIns="9144" rIns="9144" tIns="0" bIns="0">
+            <a:spAutoFit/>
+          </a:bodyPr>
+          <a:lstStyle/>
+          <a:p>
+            <a:pPr>
+              <a:spcAft>
+                <a:spcPts val="0"/>
+              </a:spcAft>
+              <a:defRPr sz="2000" b="0">
                 <a:solidFill>
                   <a:srgbClr val="17243B"/>
                 </a:solidFill>
@@ -8913,124 +9312,7 @@
               </a:defRPr>
             </a:pPr>
             <a:r>
-              <a:t>• Run the live check with your own API account</a:t>
-            </a:r>
-          </a:p>
-        </p:txBody>
-      </p:sp>
-      <p:sp>
-        <p:nvSpPr>
-          <p:cNvPr id="19" name="TextBox 18"/>
-          <p:cNvSpPr txBox="1"/>
-          <p:nvPr/>
-        </p:nvSpPr>
-        <p:spPr>
-          <a:xfrm>
-            <a:off x="6419088" y="3364992"/>
-            <a:ext cx="4892040" cy="658368"/>
-          </a:xfrm>
-          <a:prstGeom prst="rect">
-            <a:avLst/>
-          </a:prstGeom>
-          <a:noFill/>
-        </p:spPr>
-        <p:txBody>
-          <a:bodyPr wrap="square" lIns="9144" rIns="9144" tIns="0" bIns="0">
-            <a:spAutoFit/>
-          </a:bodyPr>
-          <a:lstStyle/>
-          <a:p>
-            <a:pPr>
-              <a:spcAft>
-                <a:spcPts val="0"/>
-              </a:spcAft>
-              <a:defRPr sz="1800" b="0">
-                <a:solidFill>
-                  <a:srgbClr val="17243B"/>
-                </a:solidFill>
-                <a:latin typeface="Aptos"/>
-              </a:defRPr>
-            </a:pPr>
-            <a:r>
-              <a:t>• Confirm the actual model responds</a:t>
-            </a:r>
-          </a:p>
-        </p:txBody>
-      </p:sp>
-      <p:sp>
-        <p:nvSpPr>
-          <p:cNvPr id="20" name="TextBox 19"/>
-          <p:cNvSpPr txBox="1"/>
-          <p:nvPr/>
-        </p:nvSpPr>
-        <p:spPr>
-          <a:xfrm>
-            <a:off x="6419088" y="4032504"/>
-            <a:ext cx="4892040" cy="658368"/>
-          </a:xfrm>
-          <a:prstGeom prst="rect">
-            <a:avLst/>
-          </a:prstGeom>
-          <a:noFill/>
-        </p:spPr>
-        <p:txBody>
-          <a:bodyPr wrap="square" lIns="9144" rIns="9144" tIns="0" bIns="0">
-            <a:spAutoFit/>
-          </a:bodyPr>
-          <a:lstStyle/>
-          <a:p>
-            <a:pPr>
-              <a:spcAft>
-                <a:spcPts val="0"/>
-              </a:spcAft>
-              <a:defRPr sz="1800" b="0">
-                <a:solidFill>
-                  <a:srgbClr val="17243B"/>
-                </a:solidFill>
-                <a:latin typeface="Aptos"/>
-              </a:defRPr>
-            </a:pPr>
-            <a:r>
-              <a:t>• Check the cited answer in the desktop window</a:t>
-            </a:r>
-          </a:p>
-        </p:txBody>
-      </p:sp>
-      <p:sp>
-        <p:nvSpPr>
-          <p:cNvPr id="21" name="TextBox 20"/>
-          <p:cNvSpPr txBox="1"/>
-          <p:nvPr/>
-        </p:nvSpPr>
-        <p:spPr>
-          <a:xfrm>
-            <a:off x="6419088" y="4700016"/>
-            <a:ext cx="4892040" cy="658368"/>
-          </a:xfrm>
-          <a:prstGeom prst="rect">
-            <a:avLst/>
-          </a:prstGeom>
-          <a:noFill/>
-        </p:spPr>
-        <p:txBody>
-          <a:bodyPr wrap="square" lIns="9144" rIns="9144" tIns="0" bIns="0">
-            <a:spAutoFit/>
-          </a:bodyPr>
-          <a:lstStyle/>
-          <a:p>
-            <a:pPr>
-              <a:spcAft>
-                <a:spcPts val="0"/>
-              </a:spcAft>
-              <a:defRPr sz="1800" b="0">
-                <a:solidFill>
-                  <a:srgbClr val="17243B"/>
-                </a:solidFill>
-                <a:latin typeface="Aptos"/>
-              </a:defRPr>
-            </a:pPr>
-            <a:r>
-              <a:t>• Review answer quality on your own selected data</a:t>
+              <a:t>Missing evidence, invalid keys, quota limits and timeouts have explicit outcomes.</a:t>
             </a:r>
           </a:p>
         </p:txBody>
@@ -9069,7 +9351,7 @@
               </a:defRPr>
             </a:pPr>
             <a:r>
-              <a:t>A mocked API test does not establish live account access or answer quality.</a:t>
+              <a:t>Source documents are untrusted data. The AI has no tools or authority to change the ranking.</a:t>
             </a:r>
           </a:p>
         </p:txBody>
@@ -9306,7 +9588,7 @@
               </a:defRPr>
             </a:pPr>
             <a:r>
-              <a:t>13 · DEMO + DISCUSSION</a:t>
+              <a:t>12 · VERIFICATION</a:t>
             </a:r>
           </a:p>
         </p:txBody>
@@ -9345,7 +9627,7 @@
               </a:defRPr>
             </a:pPr>
             <a:r>
-              <a:t>Demo it, explain it, check it</a:t>
+              <a:t>What the checks establish</a:t>
             </a:r>
           </a:p>
         </p:txBody>
@@ -9423,7 +9705,880 @@
               </a:defRPr>
             </a:pPr>
             <a:r>
-              <a:t>14 / 14</a:t>
+              <a:t>14 / 15</a:t>
+            </a:r>
+          </a:p>
+        </p:txBody>
+      </p:sp>
+      <p:sp>
+        <p:nvSpPr>
+          <p:cNvPr id="10" name="Rounded Rectangle 9"/>
+          <p:cNvSpPr/>
+          <p:nvPr/>
+        </p:nvSpPr>
+        <p:spPr>
+          <a:xfrm>
+            <a:off x="594360" y="1810512"/>
+            <a:ext cx="5394960" cy="3858768"/>
+          </a:xfrm>
+          <a:prstGeom prst="roundRect">
+            <a:avLst>
+              <a:gd name="adj" fmla="val 8000"/>
+            </a:avLst>
+          </a:prstGeom>
+          <a:solidFill>
+            <a:srgbClr val="EAF7EF"/>
+          </a:solidFill>
+          <a:ln>
+            <a:noFill/>
+          </a:ln>
+        </p:spPr>
+        <p:style>
+          <a:lnRef idx="1">
+            <a:schemeClr val="accent1"/>
+          </a:lnRef>
+          <a:fillRef idx="3">
+            <a:schemeClr val="accent1"/>
+          </a:fillRef>
+          <a:effectRef idx="2">
+            <a:schemeClr val="accent1"/>
+          </a:effectRef>
+          <a:fontRef idx="minor">
+            <a:schemeClr val="lt1"/>
+          </a:fontRef>
+        </p:style>
+        <p:txBody>
+          <a:bodyPr rtlCol="0" anchor="ctr"/>
+          <a:lstStyle/>
+          <a:p>
+            <a:pPr algn="ctr"/>
+          </a:p>
+        </p:txBody>
+      </p:sp>
+      <p:sp>
+        <p:nvSpPr>
+          <p:cNvPr id="11" name="TextBox 10"/>
+          <p:cNvSpPr txBox="1"/>
+          <p:nvPr/>
+        </p:nvSpPr>
+        <p:spPr>
+          <a:xfrm>
+            <a:off x="822960" y="2011680"/>
+            <a:ext cx="4919472" cy="411480"/>
+          </a:xfrm>
+          <a:prstGeom prst="rect">
+            <a:avLst/>
+          </a:prstGeom>
+          <a:noFill/>
+        </p:spPr>
+        <p:txBody>
+          <a:bodyPr wrap="square" lIns="9144" rIns="9144" tIns="0" bIns="0">
+            <a:spAutoFit/>
+          </a:bodyPr>
+          <a:lstStyle/>
+          <a:p>
+            <a:pPr>
+              <a:spcAft>
+                <a:spcPts val="0"/>
+              </a:spcAft>
+              <a:defRPr sz="2300" b="1">
+                <a:solidFill>
+                  <a:srgbClr val="18704C"/>
+                </a:solidFill>
+                <a:latin typeface="Aptos"/>
+              </a:defRPr>
+            </a:pPr>
+            <a:r>
+              <a:t>Automated verification</a:t>
+            </a:r>
+          </a:p>
+        </p:txBody>
+      </p:sp>
+      <p:sp>
+        <p:nvSpPr>
+          <p:cNvPr id="12" name="TextBox 11"/>
+          <p:cNvSpPr txBox="1"/>
+          <p:nvPr/>
+        </p:nvSpPr>
+        <p:spPr>
+          <a:xfrm>
+            <a:off x="822960" y="2697480"/>
+            <a:ext cx="4892040" cy="658368"/>
+          </a:xfrm>
+          <a:prstGeom prst="rect">
+            <a:avLst/>
+          </a:prstGeom>
+          <a:noFill/>
+        </p:spPr>
+        <p:txBody>
+          <a:bodyPr wrap="square" lIns="9144" rIns="9144" tIns="0" bIns="0">
+            <a:spAutoFit/>
+          </a:bodyPr>
+          <a:lstStyle/>
+          <a:p>
+            <a:pPr>
+              <a:spcAft>
+                <a:spcPts val="0"/>
+              </a:spcAft>
+              <a:defRPr sz="1800" b="0">
+                <a:solidFill>
+                  <a:srgbClr val="17243B"/>
+                </a:solidFill>
+                <a:latin typeface="Aptos"/>
+              </a:defRPr>
+            </a:pPr>
+            <a:r>
+              <a:t>• Budget and time boundaries; missing-data handling</a:t>
+            </a:r>
+          </a:p>
+        </p:txBody>
+      </p:sp>
+      <p:sp>
+        <p:nvSpPr>
+          <p:cNvPr id="13" name="TextBox 12"/>
+          <p:cNvSpPr txBox="1"/>
+          <p:nvPr/>
+        </p:nvSpPr>
+        <p:spPr>
+          <a:xfrm>
+            <a:off x="822960" y="3364992"/>
+            <a:ext cx="4892040" cy="658368"/>
+          </a:xfrm>
+          <a:prstGeom prst="rect">
+            <a:avLst/>
+          </a:prstGeom>
+          <a:noFill/>
+        </p:spPr>
+        <p:txBody>
+          <a:bodyPr wrap="square" lIns="9144" rIns="9144" tIns="0" bIns="0">
+            <a:spAutoFit/>
+          </a:bodyPr>
+          <a:lstStyle/>
+          <a:p>
+            <a:pPr>
+              <a:spcAft>
+                <a:spcPts val="0"/>
+              </a:spcAft>
+              <a:defRPr sz="1800" b="0">
+                <a:solidFill>
+                  <a:srgbClr val="17243B"/>
+                </a:solidFill>
+                <a:latin typeface="Aptos"/>
+              </a:defRPr>
+            </a:pPr>
+            <a:r>
+              <a:t>• All five topics and custom criteria</a:t>
+            </a:r>
+          </a:p>
+        </p:txBody>
+      </p:sp>
+      <p:sp>
+        <p:nvSpPr>
+          <p:cNvPr id="14" name="TextBox 13"/>
+          <p:cNvSpPr txBox="1"/>
+          <p:nvPr/>
+        </p:nvSpPr>
+        <p:spPr>
+          <a:xfrm>
+            <a:off x="822960" y="4032504"/>
+            <a:ext cx="4892040" cy="658368"/>
+          </a:xfrm>
+          <a:prstGeom prst="rect">
+            <a:avLst/>
+          </a:prstGeom>
+          <a:noFill/>
+        </p:spPr>
+        <p:txBody>
+          <a:bodyPr wrap="square" lIns="9144" rIns="9144" tIns="0" bIns="0">
+            <a:spAutoFit/>
+          </a:bodyPr>
+          <a:lstStyle/>
+          <a:p>
+            <a:pPr>
+              <a:spcAft>
+                <a:spcPts val="0"/>
+              </a:spcAft>
+              <a:defRPr sz="1800" b="0">
+                <a:solidFill>
+                  <a:srgbClr val="17243B"/>
+                </a:solidFill>
+                <a:latin typeface="Aptos"/>
+              </a:defRPr>
+            </a:pPr>
+            <a:r>
+              <a:t>• Python/JavaScript response parity</a:t>
+            </a:r>
+          </a:p>
+        </p:txBody>
+      </p:sp>
+      <p:sp>
+        <p:nvSpPr>
+          <p:cNvPr id="15" name="TextBox 14"/>
+          <p:cNvSpPr txBox="1"/>
+          <p:nvPr/>
+        </p:nvSpPr>
+        <p:spPr>
+          <a:xfrm>
+            <a:off x="822960" y="4700016"/>
+            <a:ext cx="4892040" cy="658368"/>
+          </a:xfrm>
+          <a:prstGeom prst="rect">
+            <a:avLst/>
+          </a:prstGeom>
+          <a:noFill/>
+        </p:spPr>
+        <p:txBody>
+          <a:bodyPr wrap="square" lIns="9144" rIns="9144" tIns="0" bIns="0">
+            <a:spAutoFit/>
+          </a:bodyPr>
+          <a:lstStyle/>
+          <a:p>
+            <a:pPr>
+              <a:spcAft>
+                <a:spcPts val="0"/>
+              </a:spcAft>
+              <a:defRPr sz="1800" b="0">
+                <a:solidFill>
+                  <a:srgbClr val="17243B"/>
+                </a:solidFill>
+                <a:latin typeface="Aptos"/>
+              </a:defRPr>
+            </a:pPr>
+            <a:r>
+              <a:t>• Mocked key/ADC providers, citations and safe errors</a:t>
+            </a:r>
+          </a:p>
+        </p:txBody>
+      </p:sp>
+      <p:sp>
+        <p:nvSpPr>
+          <p:cNvPr id="16" name="Rounded Rectangle 15"/>
+          <p:cNvSpPr/>
+          <p:nvPr/>
+        </p:nvSpPr>
+        <p:spPr>
+          <a:xfrm>
+            <a:off x="6190488" y="1810512"/>
+            <a:ext cx="5394960" cy="3858768"/>
+          </a:xfrm>
+          <a:prstGeom prst="roundRect">
+            <a:avLst>
+              <a:gd name="adj" fmla="val 8000"/>
+            </a:avLst>
+          </a:prstGeom>
+          <a:solidFill>
+            <a:srgbClr val="EDF3FF"/>
+          </a:solidFill>
+          <a:ln>
+            <a:noFill/>
+          </a:ln>
+        </p:spPr>
+        <p:style>
+          <a:lnRef idx="1">
+            <a:schemeClr val="accent1"/>
+          </a:lnRef>
+          <a:fillRef idx="3">
+            <a:schemeClr val="accent1"/>
+          </a:fillRef>
+          <a:effectRef idx="2">
+            <a:schemeClr val="accent1"/>
+          </a:effectRef>
+          <a:fontRef idx="minor">
+            <a:schemeClr val="lt1"/>
+          </a:fontRef>
+        </p:style>
+        <p:txBody>
+          <a:bodyPr rtlCol="0" anchor="ctr"/>
+          <a:lstStyle/>
+          <a:p>
+            <a:pPr algn="ctr"/>
+          </a:p>
+        </p:txBody>
+      </p:sp>
+      <p:sp>
+        <p:nvSpPr>
+          <p:cNvPr id="17" name="TextBox 16"/>
+          <p:cNvSpPr txBox="1"/>
+          <p:nvPr/>
+        </p:nvSpPr>
+        <p:spPr>
+          <a:xfrm>
+            <a:off x="6419088" y="2011680"/>
+            <a:ext cx="4919472" cy="411480"/>
+          </a:xfrm>
+          <a:prstGeom prst="rect">
+            <a:avLst/>
+          </a:prstGeom>
+          <a:noFill/>
+        </p:spPr>
+        <p:txBody>
+          <a:bodyPr wrap="square" lIns="9144" rIns="9144" tIns="0" bIns="0">
+            <a:spAutoFit/>
+          </a:bodyPr>
+          <a:lstStyle/>
+          <a:p>
+            <a:pPr>
+              <a:spcAft>
+                <a:spcPts val="0"/>
+              </a:spcAft>
+              <a:defRPr sz="2300" b="1">
+                <a:solidFill>
+                  <a:srgbClr val="255EC9"/>
+                </a:solidFill>
+                <a:latin typeface="Aptos"/>
+              </a:defRPr>
+            </a:pPr>
+            <a:r>
+              <a:t>Separate live acceptance</a:t>
+            </a:r>
+          </a:p>
+        </p:txBody>
+      </p:sp>
+      <p:sp>
+        <p:nvSpPr>
+          <p:cNvPr id="18" name="TextBox 17"/>
+          <p:cNvSpPr txBox="1"/>
+          <p:nvPr/>
+        </p:nvSpPr>
+        <p:spPr>
+          <a:xfrm>
+            <a:off x="6419088" y="2697480"/>
+            <a:ext cx="4892040" cy="658368"/>
+          </a:xfrm>
+          <a:prstGeom prst="rect">
+            <a:avLst/>
+          </a:prstGeom>
+          <a:noFill/>
+        </p:spPr>
+        <p:txBody>
+          <a:bodyPr wrap="square" lIns="9144" rIns="9144" tIns="0" bIns="0">
+            <a:spAutoFit/>
+          </a:bodyPr>
+          <a:lstStyle/>
+          <a:p>
+            <a:pPr>
+              <a:spcAft>
+                <a:spcPts val="0"/>
+              </a:spcAft>
+              <a:defRPr sz="1800" b="0">
+                <a:solidFill>
+                  <a:srgbClr val="17243B"/>
+                </a:solidFill>
+                <a:latin typeface="Aptos"/>
+              </a:defRPr>
+            </a:pPr>
+            <a:r>
+              <a:t>• Check Google ADC, then explicitly test an available model</a:t>
+            </a:r>
+          </a:p>
+        </p:txBody>
+      </p:sp>
+      <p:sp>
+        <p:nvSpPr>
+          <p:cNvPr id="19" name="TextBox 18"/>
+          <p:cNvSpPr txBox="1"/>
+          <p:nvPr/>
+        </p:nvSpPr>
+        <p:spPr>
+          <a:xfrm>
+            <a:off x="6419088" y="3364992"/>
+            <a:ext cx="4892040" cy="658368"/>
+          </a:xfrm>
+          <a:prstGeom prst="rect">
+            <a:avLst/>
+          </a:prstGeom>
+          <a:noFill/>
+        </p:spPr>
+        <p:txBody>
+          <a:bodyPr wrap="square" lIns="9144" rIns="9144" tIns="0" bIns="0">
+            <a:spAutoFit/>
+          </a:bodyPr>
+          <a:lstStyle/>
+          <a:p>
+            <a:pPr>
+              <a:spcAft>
+                <a:spcPts val="0"/>
+              </a:spcAft>
+              <a:defRPr sz="1800" b="0">
+                <a:solidFill>
+                  <a:srgbClr val="17243B"/>
+                </a:solidFill>
+                <a:latin typeface="Aptos"/>
+              </a:defRPr>
+            </a:pPr>
+            <a:r>
+              <a:t>• Confirm the actual model responds</a:t>
+            </a:r>
+          </a:p>
+        </p:txBody>
+      </p:sp>
+      <p:sp>
+        <p:nvSpPr>
+          <p:cNvPr id="20" name="TextBox 19"/>
+          <p:cNvSpPr txBox="1"/>
+          <p:nvPr/>
+        </p:nvSpPr>
+        <p:spPr>
+          <a:xfrm>
+            <a:off x="6419088" y="4032504"/>
+            <a:ext cx="4892040" cy="658368"/>
+          </a:xfrm>
+          <a:prstGeom prst="rect">
+            <a:avLst/>
+          </a:prstGeom>
+          <a:noFill/>
+        </p:spPr>
+        <p:txBody>
+          <a:bodyPr wrap="square" lIns="9144" rIns="9144" tIns="0" bIns="0">
+            <a:spAutoFit/>
+          </a:bodyPr>
+          <a:lstStyle/>
+          <a:p>
+            <a:pPr>
+              <a:spcAft>
+                <a:spcPts val="0"/>
+              </a:spcAft>
+              <a:defRPr sz="1800" b="0">
+                <a:solidFill>
+                  <a:srgbClr val="17243B"/>
+                </a:solidFill>
+                <a:latin typeface="Aptos"/>
+              </a:defRPr>
+            </a:pPr>
+            <a:r>
+              <a:t>• Check the cited answer in the desktop window</a:t>
+            </a:r>
+          </a:p>
+        </p:txBody>
+      </p:sp>
+      <p:sp>
+        <p:nvSpPr>
+          <p:cNvPr id="21" name="TextBox 20"/>
+          <p:cNvSpPr txBox="1"/>
+          <p:nvPr/>
+        </p:nvSpPr>
+        <p:spPr>
+          <a:xfrm>
+            <a:off x="6419088" y="4700016"/>
+            <a:ext cx="4892040" cy="658368"/>
+          </a:xfrm>
+          <a:prstGeom prst="rect">
+            <a:avLst/>
+          </a:prstGeom>
+          <a:noFill/>
+        </p:spPr>
+        <p:txBody>
+          <a:bodyPr wrap="square" lIns="9144" rIns="9144" tIns="0" bIns="0">
+            <a:spAutoFit/>
+          </a:bodyPr>
+          <a:lstStyle/>
+          <a:p>
+            <a:pPr>
+              <a:spcAft>
+                <a:spcPts val="0"/>
+              </a:spcAft>
+              <a:defRPr sz="1800" b="0">
+                <a:solidFill>
+                  <a:srgbClr val="17243B"/>
+                </a:solidFill>
+                <a:latin typeface="Aptos"/>
+              </a:defRPr>
+            </a:pPr>
+            <a:r>
+              <a:t>• Review answer quality on your own selected data</a:t>
+            </a:r>
+          </a:p>
+        </p:txBody>
+      </p:sp>
+      <p:sp>
+        <p:nvSpPr>
+          <p:cNvPr id="22" name="TextBox 21"/>
+          <p:cNvSpPr txBox="1"/>
+          <p:nvPr/>
+        </p:nvSpPr>
+        <p:spPr>
+          <a:xfrm>
+            <a:off x="640080" y="5833872"/>
+            <a:ext cx="10927080" cy="411480"/>
+          </a:xfrm>
+          <a:prstGeom prst="rect">
+            <a:avLst/>
+          </a:prstGeom>
+          <a:noFill/>
+        </p:spPr>
+        <p:txBody>
+          <a:bodyPr wrap="square" lIns="9144" rIns="9144" tIns="0" bIns="0">
+            <a:spAutoFit/>
+          </a:bodyPr>
+          <a:lstStyle/>
+          <a:p>
+            <a:pPr>
+              <a:spcAft>
+                <a:spcPts val="0"/>
+              </a:spcAft>
+              <a:defRPr sz="1600" b="0">
+                <a:solidFill>
+                  <a:srgbClr val="526078"/>
+                </a:solidFill>
+                <a:latin typeface="Aptos"/>
+              </a:defRPr>
+            </a:pPr>
+            <a:r>
+              <a:t>A mocked API test does not establish live account access or answer quality.</a:t>
+            </a:r>
+          </a:p>
+        </p:txBody>
+      </p:sp>
+    </p:spTree>
+  </p:cSld>
+  <p:clrMapOvr>
+    <a:masterClrMapping/>
+  </p:clrMapOvr>
+</p:sld>
+</file>
+
+<file path=ppt/slides/slide15.xml><?xml version="1.0" encoding="utf-8"?>
+<p:sld xmlns:a="http://schemas.openxmlformats.org/drawingml/2006/main" xmlns:p="http://schemas.openxmlformats.org/presentationml/2006/main" xmlns:r="http://schemas.openxmlformats.org/officeDocument/2006/relationships">
+  <p:cSld>
+    <p:bg>
+      <p:bgPr>
+        <a:solidFill>
+          <a:srgbClr val="FAFBFE"/>
+        </a:solidFill>
+        <a:effectLst/>
+      </p:bgPr>
+    </p:bg>
+    <p:spTree>
+      <p:nvGrpSpPr>
+        <p:cNvPr id="1" name=""/>
+        <p:cNvGrpSpPr/>
+        <p:nvPr/>
+      </p:nvGrpSpPr>
+      <p:grpSpPr/>
+      <p:sp>
+        <p:nvSpPr>
+          <p:cNvPr id="2" name="Rectangle 1"/>
+          <p:cNvSpPr/>
+          <p:nvPr/>
+        </p:nvSpPr>
+        <p:spPr>
+          <a:xfrm>
+            <a:off x="594360" y="365760"/>
+            <a:ext cx="228600" cy="50292"/>
+          </a:xfrm>
+          <a:prstGeom prst="rect">
+            <a:avLst/>
+          </a:prstGeom>
+          <a:solidFill>
+            <a:srgbClr val="BC3045"/>
+          </a:solidFill>
+          <a:ln>
+            <a:noFill/>
+          </a:ln>
+        </p:spPr>
+        <p:style>
+          <a:lnRef idx="1">
+            <a:schemeClr val="accent1"/>
+          </a:lnRef>
+          <a:fillRef idx="3">
+            <a:schemeClr val="accent1"/>
+          </a:fillRef>
+          <a:effectRef idx="2">
+            <a:schemeClr val="accent1"/>
+          </a:effectRef>
+          <a:fontRef idx="minor">
+            <a:schemeClr val="lt1"/>
+          </a:fontRef>
+        </p:style>
+        <p:txBody>
+          <a:bodyPr rtlCol="0" anchor="ctr"/>
+          <a:lstStyle/>
+          <a:p>
+            <a:pPr algn="ctr"/>
+          </a:p>
+        </p:txBody>
+      </p:sp>
+      <p:sp>
+        <p:nvSpPr>
+          <p:cNvPr id="3" name="Rectangle 2"/>
+          <p:cNvSpPr/>
+          <p:nvPr/>
+        </p:nvSpPr>
+        <p:spPr>
+          <a:xfrm>
+            <a:off x="822960" y="365760"/>
+            <a:ext cx="228600" cy="50292"/>
+          </a:xfrm>
+          <a:prstGeom prst="rect">
+            <a:avLst/>
+          </a:prstGeom>
+          <a:solidFill>
+            <a:srgbClr val="18704C"/>
+          </a:solidFill>
+          <a:ln>
+            <a:noFill/>
+          </a:ln>
+        </p:spPr>
+        <p:style>
+          <a:lnRef idx="1">
+            <a:schemeClr val="accent1"/>
+          </a:lnRef>
+          <a:fillRef idx="3">
+            <a:schemeClr val="accent1"/>
+          </a:fillRef>
+          <a:effectRef idx="2">
+            <a:schemeClr val="accent1"/>
+          </a:effectRef>
+          <a:fontRef idx="minor">
+            <a:schemeClr val="lt1"/>
+          </a:fontRef>
+        </p:style>
+        <p:txBody>
+          <a:bodyPr rtlCol="0" anchor="ctr"/>
+          <a:lstStyle/>
+          <a:p>
+            <a:pPr algn="ctr"/>
+          </a:p>
+        </p:txBody>
+      </p:sp>
+      <p:sp>
+        <p:nvSpPr>
+          <p:cNvPr id="4" name="Rectangle 3"/>
+          <p:cNvSpPr/>
+          <p:nvPr/>
+        </p:nvSpPr>
+        <p:spPr>
+          <a:xfrm>
+            <a:off x="1051560" y="365760"/>
+            <a:ext cx="228600" cy="50292"/>
+          </a:xfrm>
+          <a:prstGeom prst="rect">
+            <a:avLst/>
+          </a:prstGeom>
+          <a:solidFill>
+            <a:srgbClr val="255EC9"/>
+          </a:solidFill>
+          <a:ln>
+            <a:noFill/>
+          </a:ln>
+        </p:spPr>
+        <p:style>
+          <a:lnRef idx="1">
+            <a:schemeClr val="accent1"/>
+          </a:lnRef>
+          <a:fillRef idx="3">
+            <a:schemeClr val="accent1"/>
+          </a:fillRef>
+          <a:effectRef idx="2">
+            <a:schemeClr val="accent1"/>
+          </a:effectRef>
+          <a:fontRef idx="minor">
+            <a:schemeClr val="lt1"/>
+          </a:fontRef>
+        </p:style>
+        <p:txBody>
+          <a:bodyPr rtlCol="0" anchor="ctr"/>
+          <a:lstStyle/>
+          <a:p>
+            <a:pPr algn="ctr"/>
+          </a:p>
+        </p:txBody>
+      </p:sp>
+      <p:sp>
+        <p:nvSpPr>
+          <p:cNvPr id="5" name="Rectangle 4"/>
+          <p:cNvSpPr/>
+          <p:nvPr/>
+        </p:nvSpPr>
+        <p:spPr>
+          <a:xfrm>
+            <a:off x="1280160" y="365760"/>
+            <a:ext cx="228600" cy="50292"/>
+          </a:xfrm>
+          <a:prstGeom prst="rect">
+            <a:avLst/>
+          </a:prstGeom>
+          <a:solidFill>
+            <a:srgbClr val="8A630A"/>
+          </a:solidFill>
+          <a:ln>
+            <a:noFill/>
+          </a:ln>
+        </p:spPr>
+        <p:style>
+          <a:lnRef idx="1">
+            <a:schemeClr val="accent1"/>
+          </a:lnRef>
+          <a:fillRef idx="3">
+            <a:schemeClr val="accent1"/>
+          </a:fillRef>
+          <a:effectRef idx="2">
+            <a:schemeClr val="accent1"/>
+          </a:effectRef>
+          <a:fontRef idx="minor">
+            <a:schemeClr val="lt1"/>
+          </a:fontRef>
+        </p:style>
+        <p:txBody>
+          <a:bodyPr rtlCol="0" anchor="ctr"/>
+          <a:lstStyle/>
+          <a:p>
+            <a:pPr algn="ctr"/>
+          </a:p>
+        </p:txBody>
+      </p:sp>
+      <p:sp>
+        <p:nvSpPr>
+          <p:cNvPr id="6" name="TextBox 5"/>
+          <p:cNvSpPr txBox="1"/>
+          <p:nvPr/>
+        </p:nvSpPr>
+        <p:spPr>
+          <a:xfrm>
+            <a:off x="594360" y="566928"/>
+            <a:ext cx="10881360" cy="256032"/>
+          </a:xfrm>
+          <a:prstGeom prst="rect">
+            <a:avLst/>
+          </a:prstGeom>
+          <a:noFill/>
+        </p:spPr>
+        <p:txBody>
+          <a:bodyPr wrap="square" lIns="9144" rIns="9144" tIns="0" bIns="0">
+            <a:spAutoFit/>
+          </a:bodyPr>
+          <a:lstStyle/>
+          <a:p>
+            <a:pPr>
+              <a:spcAft>
+                <a:spcPts val="0"/>
+              </a:spcAft>
+              <a:defRPr sz="1100" b="1">
+                <a:solidFill>
+                  <a:srgbClr val="255EC9"/>
+                </a:solidFill>
+                <a:latin typeface="Aptos"/>
+              </a:defRPr>
+            </a:pPr>
+            <a:r>
+              <a:t>13 · DEMO + DISCUSSION</a:t>
+            </a:r>
+          </a:p>
+        </p:txBody>
+      </p:sp>
+      <p:sp>
+        <p:nvSpPr>
+          <p:cNvPr id="7" name="TextBox 6"/>
+          <p:cNvSpPr txBox="1"/>
+          <p:nvPr/>
+        </p:nvSpPr>
+        <p:spPr>
+          <a:xfrm>
+            <a:off x="594360" y="932688"/>
+            <a:ext cx="10972800" cy="685800"/>
+          </a:xfrm>
+          <a:prstGeom prst="rect">
+            <a:avLst/>
+          </a:prstGeom>
+          <a:noFill/>
+        </p:spPr>
+        <p:txBody>
+          <a:bodyPr wrap="square" lIns="9144" rIns="9144" tIns="0" bIns="0">
+            <a:spAutoFit/>
+          </a:bodyPr>
+          <a:lstStyle/>
+          <a:p>
+            <a:pPr>
+              <a:spcAft>
+                <a:spcPts val="0"/>
+              </a:spcAft>
+              <a:defRPr sz="3400" b="1">
+                <a:solidFill>
+                  <a:srgbClr val="17243B"/>
+                </a:solidFill>
+                <a:latin typeface="Aptos"/>
+              </a:defRPr>
+            </a:pPr>
+            <a:r>
+              <a:t>Demo it, explain it, check it</a:t>
+            </a:r>
+          </a:p>
+        </p:txBody>
+      </p:sp>
+      <p:sp>
+        <p:nvSpPr>
+          <p:cNvPr id="8" name="TextBox 7"/>
+          <p:cNvSpPr txBox="1"/>
+          <p:nvPr/>
+        </p:nvSpPr>
+        <p:spPr>
+          <a:xfrm>
+            <a:off x="594360" y="6455664"/>
+            <a:ext cx="9875520" cy="182880"/>
+          </a:xfrm>
+          <a:prstGeom prst="rect">
+            <a:avLst/>
+          </a:prstGeom>
+          <a:noFill/>
+        </p:spPr>
+        <p:txBody>
+          <a:bodyPr wrap="square" lIns="9144" rIns="9144" tIns="0" bIns="0">
+            <a:spAutoFit/>
+          </a:bodyPr>
+          <a:lstStyle/>
+          <a:p>
+            <a:pPr>
+              <a:spcAft>
+                <a:spcPts val="0"/>
+              </a:spcAft>
+              <a:defRPr sz="900" b="0">
+                <a:solidFill>
+                  <a:srgbClr val="526078"/>
+                </a:solidFill>
+                <a:latin typeface="Aptos"/>
+              </a:defRPr>
+            </a:pPr>
+            <a:r>
+              <a:t>JINNI · CODE WALKTHROUGH · FICTIONAL DEMO DATA</a:t>
+            </a:r>
+          </a:p>
+        </p:txBody>
+      </p:sp>
+      <p:sp>
+        <p:nvSpPr>
+          <p:cNvPr id="9" name="TextBox 8"/>
+          <p:cNvSpPr txBox="1"/>
+          <p:nvPr/>
+        </p:nvSpPr>
+        <p:spPr>
+          <a:xfrm>
+            <a:off x="11064240" y="6419088"/>
+            <a:ext cx="594360" cy="228600"/>
+          </a:xfrm>
+          <a:prstGeom prst="rect">
+            <a:avLst/>
+          </a:prstGeom>
+          <a:noFill/>
+        </p:spPr>
+        <p:txBody>
+          <a:bodyPr wrap="square" lIns="9144" rIns="9144" tIns="0" bIns="0">
+            <a:spAutoFit/>
+          </a:bodyPr>
+          <a:lstStyle/>
+          <a:p>
+            <a:pPr>
+              <a:spcAft>
+                <a:spcPts val="0"/>
+              </a:spcAft>
+              <a:defRPr sz="1000" b="0">
+                <a:solidFill>
+                  <a:srgbClr val="526078"/>
+                </a:solidFill>
+                <a:latin typeface="Aptos"/>
+              </a:defRPr>
+            </a:pPr>
+            <a:r>
+              <a:t>15 / 15</a:t>
             </a:r>
           </a:p>
         </p:txBody>
@@ -9792,7 +10947,7 @@
               </a:defRPr>
             </a:pPr>
             <a:r>
-              <a:t>Ask OpenAI to explain the result; inspect the returned quote.</a:t>
+              <a:t>Ask the selected provider to explain the result; inspect the returned quote.</a:t>
             </a:r>
           </a:p>
         </p:txBody>
@@ -10122,7 +11277,7 @@
               </a:defRPr>
             </a:pPr>
             <a:r>
-              <a:t>Optional live check: uv run python -m scripts.verify_openai --decision</a:t>
+              <a:t>ADC check: uv run python -m scripts.verify_vertex --project YOUR_PROJECT_ID</a:t>
             </a:r>
           </a:p>
         </p:txBody>
@@ -10476,7 +11631,7 @@
               </a:defRPr>
             </a:pPr>
             <a:r>
-              <a:t>02 / 14</a:t>
+              <a:t>02 / 15</a:t>
             </a:r>
           </a:p>
         </p:txBody>
@@ -11403,7 +12558,7 @@
               </a:defRPr>
             </a:pPr>
             <a:r>
-              <a:t>03 / 14</a:t>
+              <a:t>03 / 15</a:t>
             </a:r>
           </a:p>
         </p:txBody>
@@ -12444,7 +13599,7 @@
               </a:defRPr>
             </a:pPr>
             <a:r>
-              <a:t>04 / 14</a:t>
+              <a:t>04 / 15</a:t>
             </a:r>
           </a:p>
         </p:txBody>
@@ -12684,7 +13839,7 @@
               </a:defRPr>
             </a:pPr>
             <a:r>
-              <a:t>• Optional OpenAI through the backend</a:t>
+              <a:t>• OpenAI or Google Vertex AI through the backend</a:t>
             </a:r>
           </a:p>
         </p:txBody>
@@ -13317,7 +14472,7 @@
               </a:defRPr>
             </a:pPr>
             <a:r>
-              <a:t>05 / 14</a:t>
+              <a:t>05 / 15</a:t>
             </a:r>
           </a:p>
         </p:txBody>
@@ -14819,7 +15974,7 @@
               </a:defRPr>
             </a:pPr>
             <a:r>
-              <a:t>06 / 14</a:t>
+              <a:t>06 / 15</a:t>
             </a:r>
           </a:p>
         </p:txBody>
@@ -15860,7 +17015,7 @@
               </a:defRPr>
             </a:pPr>
             <a:r>
-              <a:t>07 / 14</a:t>
+              <a:t>07 / 15</a:t>
             </a:r>
           </a:p>
         </p:txBody>
@@ -16493,7 +17648,7 @@
               </a:defRPr>
             </a:pPr>
             <a:r>
-              <a:t>08 / 14</a:t>
+              <a:t>08 / 15</a:t>
             </a:r>
           </a:p>
         </p:txBody>
@@ -18155,7 +19310,7 @@
               </a:defRPr>
             </a:pPr>
             <a:r>
-              <a:t>How OpenAI supports the decision</a:t>
+              <a:t>How AI supports the decision</a:t>
             </a:r>
           </a:p>
         </p:txBody>
@@ -18233,7 +19388,7 @@
               </a:defRPr>
             </a:pPr>
             <a:r>
-              <a:t>09 / 14</a:t>
+              <a:t>09 / 15</a:t>
             </a:r>
           </a:p>
         </p:txBody>
@@ -18719,7 +19874,7 @@
               </a:defRPr>
             </a:pPr>
             <a:r>
-              <a:t>OpenAI returns a structured answer.</a:t>
+              <a:t>The selected provider returns structured text.</a:t>
             </a:r>
           </a:p>
         </p:txBody>
@@ -18920,7 +20075,7 @@
               </a:defRPr>
             </a:pPr>
             <a:r>
-              <a:t>Python ranks the options. OpenAI explains the supplied results and evidence.</a:t>
+              <a:t>Python ranks the options. The AI explains supplied results and evidence.</a:t>
             </a:r>
           </a:p>
         </p:txBody>

</xml_diff>